<commit_message>
Slides 1–16 e 25–32; ajuste da figura f31_formacao
Co-Authored-By: Claude Sonnet 5.5 <noreply@anthropic.com>
Claude-Session: https://claude.ai/code/session_01LQk7H4UNLk2VXi2CstzPTX
</commit_message>
<xml_diff>
--- a/livro_ia_educacao/saida/pptx/Cap23_slides.pptx
+++ b/livro_ia_educacao/saida/pptx/Cap23_slides.pptx
@@ -29,10 +29,9 @@
     <p:sldId id="277" r:id="rId23"/>
     <p:sldId id="278" r:id="rId24"/>
     <p:sldId id="279" r:id="rId25"/>
-    <p:sldId id="280" r:id="rId26"/>
   </p:sldIdLst>
   <p:notesMasterIdLst>
-    <p:notesMasterId r:id="rId27"/>
+    <p:notesMasterId r:id="rId26"/>
   </p:notesMasterIdLst>
   <p:sldSz cx="12192000" cy="6858000"/>
   <p:notesSz cx="6858000" cy="12192000"/>
@@ -1406,7 +1405,7 @@
           <a:p>
             <a:r>
               <a:rPr lang="en-US" dirty="0"/>
-              <a:t>Respeitar a autonomia docente inclui reconhecer que alguns professores decidam não usar IA em certas tarefas. Distinga recusa fundamentada, que é decisão profissional, de falta de informação, que se resolve com estudo e prática. Convide a uma tentativa pequena e a registrar resultados.</a:t>
+              <a:t>O que a pesquisa permite afirmar. Formação: revisões associam características a mudança de prática, com variação e cautela na transferência ao Brasil. Ganhos de tempo com IA: poucas evidências robustas para professores. Acessibilidade e IA: desenho universal é consolidado, mas estudos controlados sobre IA para materiais acessíveis na escola são escassos.</a:t>
             </a:r>
             <a:endParaRPr lang="en-US" dirty="0"/>
           </a:p>
@@ -1582,7 +1581,7 @@
           <a:p>
             <a:r>
               <a:rPr lang="en-US" dirty="0"/>
-              <a:t>O que a pesquisa permite afirmar. Formação: revisões associam características a mudança de prática, com variação e cautela na transferência ao Brasil. Ganhos de tempo com IA: poucas evidências robustas para professores. Acessibilidade e IA: desenho universal é consolidado, mas estudos controlados sobre IA para materiais acessíveis na escola são escassos.</a:t>
+              <a:t>Riscos do capítulo: adaptações erradas, exposição de dados, estigma, excesso de confiança em ferramentas como substitutas de intérpretes e profissionais de apoio, intensificação do trabalho e pressão por adoção. Quando dispensar: pedido com dados identificáveis, material crítico para segurança ou saúde, ou quando não se pode verificar.</a:t>
             </a:r>
             <a:endParaRPr lang="en-US" dirty="0"/>
           </a:p>
@@ -1670,7 +1669,7 @@
           <a:p>
             <a:r>
               <a:rPr lang="en-US" dirty="0"/>
-              <a:t>Riscos do capítulo: adaptações erradas, exposição de dados, estigma, excesso de confiança em ferramentas como substitutas de intérpretes e profissionais de apoio, intensificação do trabalho e pressão por adoção. Quando dispensar: pedido com dados identificáveis, material crítico para segurança ou saúde, ou quando não se pode verificar.</a:t>
+              <a:t>Síntese: acessibilidade, trabalho e formação, ligados por uma pequena caixa tracejada: IA, rascunhos sob verificação. Peça que cada um diga qual bloco fortalecerá primeiro.</a:t>
             </a:r>
             <a:endParaRPr lang="en-US" dirty="0"/>
           </a:p>
@@ -1758,7 +1757,7 @@
           <a:p>
             <a:r>
               <a:rPr lang="en-US" dirty="0"/>
-              <a:t>Síntese: acessibilidade, trabalho e formação, ligados por uma pequena caixa tracejada: IA, rascunhos sob verificação. Peça que cada um diga qual bloco fortalecerá primeiro.</a:t>
+              <a:t>Releia os pontos. Sugira o bilhete anônimo para os estudantes: qual formato ajuda você mais a estudar, texto, esquema, áudio ou vídeo? O que atrapalha?</a:t>
             </a:r>
             <a:endParaRPr lang="en-US" dirty="0"/>
           </a:p>
@@ -1846,7 +1845,7 @@
           <a:p>
             <a:r>
               <a:rPr lang="en-US" dirty="0"/>
-              <a:t>Releia os pontos. Sugira o bilhete anônimo para os estudantes: qual formato ajuda você mais a estudar, texto, esquema, áudio ou vídeo? O que atrapalha?</a:t>
+              <a:t>Dê 5 minutos. Convide pares a combinar uma pergunta de prática para um ciclo de estudo.</a:t>
             </a:r>
             <a:endParaRPr lang="en-US" dirty="0"/>
           </a:p>
@@ -1934,7 +1933,7 @@
           <a:p>
             <a:r>
               <a:rPr lang="en-US" dirty="0"/>
-              <a:t>Dê 5 minutos. Convide pares a combinar uma pergunta de prática para um ciclo de estudo.</a:t>
+              <a:t>Encerramento. Convide a turma a escolher uma ideia para experimentar nesta semana.</a:t>
             </a:r>
             <a:endParaRPr lang="en-US" dirty="0"/>
           </a:p>
@@ -1958,94 +1957,6 @@
             <a:fld id="{F7021451-1387-4CA6-816F-3879F97B5CBC}" type="slidenum">
               <a:rPr lang="en-US"/>
               <a:t>24</a:t>
-            </a:fld>
-            <a:endParaRPr lang="en-US"/>
-          </a:p>
-        </p:txBody>
-      </p:sp>
-    </p:spTree>
-    <p:extLst>
-      <p:ext uri="{BB962C8B-B14F-4D97-AF65-F5344CB8AC3E}">
-        <p14:creationId xmlns:p14="http://schemas.microsoft.com/office/powerpoint/2010/main" val="1024086991"/>
-      </p:ext>
-    </p:extLst>
-  </p:cSld>
-  <p:clrMapOvr>
-    <a:masterClrMapping/>
-  </p:clrMapOvr>
-</p:notes>
-</file>
-
-<file path=ppt/notesSlides/notesSlide25.xml><?xml version="1.0" encoding="utf-8"?>
-<p:notes xmlns:a="http://schemas.openxmlformats.org/drawingml/2006/main" xmlns:r="http://schemas.openxmlformats.org/officeDocument/2006/relationships" xmlns:p="http://schemas.openxmlformats.org/presentationml/2006/main">
-  <p:cSld>
-    <p:spTree>
-      <p:nvGrpSpPr>
-        <p:cNvPr id="1" name=""/>
-        <p:cNvGrpSpPr/>
-        <p:nvPr/>
-      </p:nvGrpSpPr>
-      <p:grpSpPr>
-        <a:xfrm>
-          <a:off x="0" y="0"/>
-          <a:ext cx="0" cy="0"/>
-          <a:chOff x="0" y="0"/>
-          <a:chExt cx="0" cy="0"/>
-        </a:xfrm>
-      </p:grpSpPr>
-      <p:sp>
-        <p:nvSpPr>
-          <p:cNvPr id="2" name="Slide Image Placeholder 1"/>
-          <p:cNvSpPr>
-            <a:spLocks noGrp="1" noRot="1" noChangeAspect="1"/>
-          </p:cNvSpPr>
-          <p:nvPr>
-            <p:ph type="sldImg"/>
-          </p:nvPr>
-        </p:nvSpPr>
-        <p:spPr/>
-      </p:sp>
-      <p:sp>
-        <p:nvSpPr>
-          <p:cNvPr id="3" name="Notes Placeholder 2"/>
-          <p:cNvSpPr>
-            <a:spLocks noGrp="1"/>
-          </p:cNvSpPr>
-          <p:nvPr>
-            <p:ph type="body" idx="1"/>
-          </p:nvPr>
-        </p:nvSpPr>
-        <p:spPr/>
-        <p:txBody>
-          <a:bodyPr/>
-          <a:lstStyle/>
-          <a:p>
-            <a:r>
-              <a:rPr lang="en-US" dirty="0"/>
-              <a:t>Encerramento. Convide a turma a escolher uma ideia para experimentar nesta semana.</a:t>
-            </a:r>
-            <a:endParaRPr lang="en-US" dirty="0"/>
-          </a:p>
-        </p:txBody>
-      </p:sp>
-      <p:sp>
-        <p:nvSpPr>
-          <p:cNvPr id="4" name="Slide Number Placeholder 3"/>
-          <p:cNvSpPr>
-            <a:spLocks noGrp="1"/>
-          </p:cNvSpPr>
-          <p:nvPr>
-            <p:ph type="sldNum" sz="quarter" idx="10"/>
-          </p:nvPr>
-        </p:nvSpPr>
-        <p:spPr/>
-        <p:txBody>
-          <a:bodyPr/>
-          <a:lstStyle/>
-          <a:p>
-            <a:fld id="{F7021451-1387-4CA6-816F-3879F97B5CBC}" type="slidenum">
-              <a:rPr lang="en-US"/>
-              <a:t>25</a:t>
             </a:fld>
             <a:endParaRPr lang="en-US"/>
           </a:p>
@@ -8610,7 +8521,7 @@
                 <a:ea typeface="Cambria" pitchFamily="34" charset="-122"/>
                 <a:cs typeface="Cambria" pitchFamily="34" charset="-120"/>
               </a:rPr>
-              <a:t>Quem não quer usar IA</a:t>
+              <a:t>O que a pesquisa permite afirmar</a:t>
             </a:r>
             <a:endParaRPr lang="en-US" sz="3400" dirty="0"/>
           </a:p>
@@ -8625,11 +8536,11 @@
         <p:spPr>
           <a:xfrm>
             <a:off x="548640" y="1463040"/>
-            <a:ext cx="5394960" cy="4572000"/>
+            <a:ext cx="3505200" cy="4480560"/>
           </a:xfrm>
           <a:prstGeom prst="roundRect">
             <a:avLst>
-              <a:gd name="adj" fmla="val 3000"/>
+              <a:gd name="adj" fmla="val 3913"/>
             </a:avLst>
           </a:prstGeom>
           <a:solidFill>
@@ -8641,6 +8552,13 @@
             </a:solidFill>
             <a:prstDash val="solid"/>
           </a:ln>
+          <a:effectLst>
+            <a:outerShdw sx="100000" sy="100000" kx="0" ky="0" algn="bl" rotWithShape="0" blurRad="76200" dist="25400" dir="5400000">
+              <a:srgbClr val="000000">
+                <a:alpha val="12000"/>
+              </a:srgbClr>
+            </a:outerShdw>
+          </a:effectLst>
         </p:spPr>
       </p:sp>
       <p:sp>
@@ -8651,13 +8569,184 @@
         </p:nvSpPr>
         <p:spPr>
           <a:xfrm>
-            <a:off x="548640" y="1463040"/>
-            <a:ext cx="5394960" cy="731520"/>
+            <a:off x="777240" y="1691640"/>
+            <a:ext cx="640080" cy="640080"/>
+          </a:xfrm>
+          <a:prstGeom prst="ellipse">
+            <a:avLst/>
+          </a:prstGeom>
+          <a:solidFill>
+            <a:srgbClr val="6D3B6E"/>
+          </a:solidFill>
+          <a:ln w="12700">
+            <a:solidFill>
+              <a:srgbClr val="6D3B6E"/>
+            </a:solidFill>
+            <a:prstDash val="solid"/>
+          </a:ln>
+        </p:spPr>
+      </p:sp>
+      <p:sp>
+        <p:nvSpPr>
+          <p:cNvPr id="6" name="Text 3"/>
+          <p:cNvSpPr txBox="1"/>
+          <p:nvPr/>
+        </p:nvSpPr>
+        <p:spPr>
+          <a:xfrm>
+            <a:off x="777240" y="1691640"/>
+            <a:ext cx="640080" cy="640080"/>
+          </a:xfrm>
+          <a:prstGeom prst="rect">
+            <a:avLst/>
+          </a:prstGeom>
+          <a:noFill/>
+          <a:ln/>
+        </p:spPr>
+        <p:txBody>
+          <a:bodyPr wrap="square" lIns="0" tIns="0" rIns="0" bIns="0" rtlCol="0" anchor="ctr"/>
+          <a:lstStyle/>
+          <a:p>
+            <a:pPr algn="ctr" indent="0" marL="0">
+              <a:buNone/>
+            </a:pPr>
+            <a:r>
+              <a:rPr lang="en-US" sz="1600" b="1" dirty="0">
+                <a:solidFill>
+                  <a:srgbClr val="FFFFFF"/>
+                </a:solidFill>
+                <a:latin typeface="Cambria" pitchFamily="34" charset="0"/>
+                <a:ea typeface="Cambria" pitchFamily="34" charset="-122"/>
+                <a:cs typeface="Cambria" pitchFamily="34" charset="-120"/>
+              </a:rPr>
+              <a:t>1</a:t>
+            </a:r>
+            <a:endParaRPr lang="en-US" sz="1600" dirty="0"/>
+          </a:p>
+        </p:txBody>
+      </p:sp>
+      <p:sp>
+        <p:nvSpPr>
+          <p:cNvPr id="7" name="Text 4"/>
+          <p:cNvSpPr txBox="1"/>
+          <p:nvPr/>
+        </p:nvSpPr>
+        <p:spPr>
+          <a:xfrm>
+            <a:off x="777240" y="2468880"/>
+            <a:ext cx="3048000" cy="822960"/>
+          </a:xfrm>
+          <a:prstGeom prst="rect">
+            <a:avLst/>
+          </a:prstGeom>
+          <a:noFill/>
+          <a:ln/>
+        </p:spPr>
+        <p:txBody>
+          <a:bodyPr wrap="square" lIns="0" tIns="0" rIns="0" bIns="0" rtlCol="0" anchor="t"/>
+          <a:lstStyle/>
+          <a:p>
+            <a:pPr indent="0" marL="0">
+              <a:buNone/>
+            </a:pPr>
+            <a:r>
+              <a:rPr lang="en-US" sz="2000" b="1" dirty="0">
+                <a:solidFill>
+                  <a:srgbClr val="5A2E2A"/>
+                </a:solidFill>
+                <a:latin typeface="Cambria" pitchFamily="34" charset="0"/>
+                <a:ea typeface="Cambria" pitchFamily="34" charset="-122"/>
+                <a:cs typeface="Cambria" pitchFamily="34" charset="-120"/>
+              </a:rPr>
+              <a:t>Formação docente</a:t>
+            </a:r>
+            <a:endParaRPr lang="en-US" sz="2000" dirty="0"/>
+          </a:p>
+        </p:txBody>
+      </p:sp>
+      <p:sp>
+        <p:nvSpPr>
+          <p:cNvPr id="8" name="Text 5"/>
+          <p:cNvSpPr txBox="1"/>
+          <p:nvPr/>
+        </p:nvSpPr>
+        <p:spPr>
+          <a:xfrm>
+            <a:off x="777240" y="3337560"/>
+            <a:ext cx="3048000" cy="2468880"/>
+          </a:xfrm>
+          <a:prstGeom prst="rect">
+            <a:avLst/>
+          </a:prstGeom>
+          <a:noFill/>
+          <a:ln/>
+        </p:spPr>
+        <p:txBody>
+          <a:bodyPr wrap="square" lIns="0" tIns="0" rIns="0" bIns="0" rtlCol="0" anchor="t"/>
+          <a:lstStyle/>
+          <a:p>
+            <a:pPr indent="0" marL="0">
+              <a:buNone/>
+            </a:pPr>
+            <a:r>
+              <a:rPr lang="en-US" sz="1700" dirty="0">
+                <a:solidFill>
+                  <a:srgbClr val="3B2A2A"/>
+                </a:solidFill>
+              </a:rPr>
+              <a:t>Ativa, colaborativa e sustentada se associa a mudança de prática, com variação.</a:t>
+            </a:r>
+            <a:endParaRPr lang="en-US" sz="1700" dirty="0"/>
+          </a:p>
+        </p:txBody>
+      </p:sp>
+      <p:sp>
+        <p:nvSpPr>
+          <p:cNvPr id="9" name="Shape 6"/>
+          <p:cNvSpPr/>
+          <p:nvPr/>
+        </p:nvSpPr>
+        <p:spPr>
+          <a:xfrm>
+            <a:off x="4328160" y="1463040"/>
+            <a:ext cx="3505200" cy="4480560"/>
           </a:xfrm>
           <a:prstGeom prst="roundRect">
             <a:avLst>
-              <a:gd name="adj" fmla="val 18750"/>
+              <a:gd name="adj" fmla="val 3913"/>
             </a:avLst>
+          </a:prstGeom>
+          <a:solidFill>
+            <a:srgbClr val="F7EFE6"/>
+          </a:solidFill>
+          <a:ln w="12700">
+            <a:solidFill>
+              <a:srgbClr val="F7EFE6"/>
+            </a:solidFill>
+            <a:prstDash val="solid"/>
+          </a:ln>
+          <a:effectLst>
+            <a:outerShdw sx="100000" sy="100000" kx="0" ky="0" algn="bl" rotWithShape="0" blurRad="76200" dist="25400" dir="5400000">
+              <a:srgbClr val="000000">
+                <a:alpha val="12000"/>
+              </a:srgbClr>
+            </a:outerShdw>
+          </a:effectLst>
+        </p:spPr>
+      </p:sp>
+      <p:sp>
+        <p:nvSpPr>
+          <p:cNvPr id="10" name="Shape 7"/>
+          <p:cNvSpPr/>
+          <p:nvPr/>
+        </p:nvSpPr>
+        <p:spPr>
+          <a:xfrm>
+            <a:off x="4556760" y="1691640"/>
+            <a:ext cx="640080" cy="640080"/>
+          </a:xfrm>
+          <a:prstGeom prst="ellipse">
+            <a:avLst/>
           </a:prstGeom>
           <a:solidFill>
             <a:srgbClr val="2A9D8F"/>
@@ -8672,14 +8761,14 @@
       </p:sp>
       <p:sp>
         <p:nvSpPr>
-          <p:cNvPr id="6" name="Text 3"/>
-          <p:cNvSpPr txBox="1"/>
-          <p:nvPr/>
-        </p:nvSpPr>
-        <p:spPr>
-          <a:xfrm>
-            <a:off x="777240" y="1463040"/>
-            <a:ext cx="4937760" cy="731520"/>
+          <p:cNvPr id="11" name="Text 8"/>
+          <p:cNvSpPr txBox="1"/>
+          <p:nvPr/>
+        </p:nvSpPr>
+        <p:spPr>
+          <a:xfrm>
+            <a:off x="4556760" y="1691640"/>
+            <a:ext cx="640080" cy="640080"/>
           </a:xfrm>
           <a:prstGeom prst="rect">
             <a:avLst/>
@@ -8691,11 +8780,11 @@
           <a:bodyPr wrap="square" lIns="0" tIns="0" rIns="0" bIns="0" rtlCol="0" anchor="ctr"/>
           <a:lstStyle/>
           <a:p>
-            <a:pPr indent="0" marL="0">
-              <a:buNone/>
-            </a:pPr>
-            <a:r>
-              <a:rPr lang="en-US" sz="2200" b="1" dirty="0">
+            <a:pPr algn="ctr" indent="0" marL="0">
+              <a:buNone/>
+            </a:pPr>
+            <a:r>
+              <a:rPr lang="en-US" sz="1600" b="1" dirty="0">
                 <a:solidFill>
                   <a:srgbClr val="FFFFFF"/>
                 </a:solidFill>
@@ -8703,22 +8792,22 @@
                 <a:ea typeface="Cambria" pitchFamily="34" charset="-122"/>
                 <a:cs typeface="Cambria" pitchFamily="34" charset="-120"/>
               </a:rPr>
-              <a:t>Recusa fundamentada</a:t>
-            </a:r>
-            <a:endParaRPr lang="en-US" sz="2200" dirty="0"/>
-          </a:p>
-        </p:txBody>
-      </p:sp>
-      <p:sp>
-        <p:nvSpPr>
-          <p:cNvPr id="7" name="Text 4"/>
-          <p:cNvSpPr txBox="1"/>
-          <p:nvPr/>
-        </p:nvSpPr>
-        <p:spPr>
-          <a:xfrm>
-            <a:off x="822960" y="2377440"/>
-            <a:ext cx="4846320" cy="3566160"/>
+              <a:t>2</a:t>
+            </a:r>
+            <a:endParaRPr lang="en-US" sz="1600" dirty="0"/>
+          </a:p>
+        </p:txBody>
+      </p:sp>
+      <p:sp>
+        <p:nvSpPr>
+          <p:cNvPr id="12" name="Text 9"/>
+          <p:cNvSpPr txBox="1"/>
+          <p:nvPr/>
+        </p:nvSpPr>
+        <p:spPr>
+          <a:xfrm>
+            <a:off x="4556760" y="2468880"/>
+            <a:ext cx="3048000" cy="822960"/>
           </a:xfrm>
           <a:prstGeom prst="rect">
             <a:avLst/>
@@ -8730,12 +8819,47 @@
           <a:bodyPr wrap="square" lIns="0" tIns="0" rIns="0" bIns="0" rtlCol="0" anchor="t"/>
           <a:lstStyle/>
           <a:p>
-            <a:pPr marL="342900" indent="-342900">
-              <a:spcAft>
-                <a:spcPts val="800"/>
-              </a:spcAft>
-              <a:buSzPct val="100000"/>
-              <a:buChar char="•"/>
+            <a:pPr indent="0" marL="0">
+              <a:buNone/>
+            </a:pPr>
+            <a:r>
+              <a:rPr lang="en-US" sz="2000" b="1" dirty="0">
+                <a:solidFill>
+                  <a:srgbClr val="5A2E2A"/>
+                </a:solidFill>
+                <a:latin typeface="Cambria" pitchFamily="34" charset="0"/>
+                <a:ea typeface="Cambria" pitchFamily="34" charset="-122"/>
+                <a:cs typeface="Cambria" pitchFamily="34" charset="-120"/>
+              </a:rPr>
+              <a:t>Ganho de tempo</a:t>
+            </a:r>
+            <a:endParaRPr lang="en-US" sz="2000" dirty="0"/>
+          </a:p>
+        </p:txBody>
+      </p:sp>
+      <p:sp>
+        <p:nvSpPr>
+          <p:cNvPr id="13" name="Text 10"/>
+          <p:cNvSpPr txBox="1"/>
+          <p:nvPr/>
+        </p:nvSpPr>
+        <p:spPr>
+          <a:xfrm>
+            <a:off x="4556760" y="3337560"/>
+            <a:ext cx="3048000" cy="2468880"/>
+          </a:xfrm>
+          <a:prstGeom prst="rect">
+            <a:avLst/>
+          </a:prstGeom>
+          <a:noFill/>
+          <a:ln/>
+        </p:spPr>
+        <p:txBody>
+          <a:bodyPr wrap="square" lIns="0" tIns="0" rIns="0" bIns="0" rtlCol="0" anchor="t"/>
+          <a:lstStyle/>
+          <a:p>
+            <a:pPr indent="0" marL="0">
+              <a:buNone/>
             </a:pPr>
             <a:r>
               <a:rPr lang="en-US" sz="1700" dirty="0">
@@ -8743,80 +8867,26 @@
                   <a:srgbClr val="3B2A2A"/>
                 </a:solidFill>
               </a:rPr>
-              <a:t>Razões pedagógicas, éticas ou de contexto</a:t>
+              <a:t>Poucas evidências robustas para professores brasileiros; depende da tarefa.</a:t>
             </a:r>
             <a:endParaRPr lang="en-US" sz="1700" dirty="0"/>
           </a:p>
-          <a:p>
-            <a:pPr marL="342900" indent="-342900">
-              <a:spcAft>
-                <a:spcPts val="800"/>
-              </a:spcAft>
-              <a:buSzPct val="100000"/>
-              <a:buChar char="•"/>
-            </a:pPr>
-            <a:r>
-              <a:rPr lang="en-US" sz="1700" dirty="0">
-                <a:solidFill>
-                  <a:srgbClr val="3B2A2A"/>
-                </a:solidFill>
-              </a:rPr>
-              <a:t>É decisão profissional</a:t>
-            </a:r>
-            <a:endParaRPr lang="en-US" sz="1700" dirty="0"/>
-          </a:p>
-          <a:p>
-            <a:pPr marL="342900" indent="-342900">
-              <a:spcAft>
-                <a:spcPts val="800"/>
-              </a:spcAft>
-              <a:buSzPct val="100000"/>
-              <a:buChar char="•"/>
-            </a:pPr>
-            <a:r>
-              <a:rPr lang="en-US" sz="1700" dirty="0">
-                <a:solidFill>
-                  <a:srgbClr val="3B2A2A"/>
-                </a:solidFill>
-              </a:rPr>
-              <a:t>Merece espaço de discussão</a:t>
-            </a:r>
-            <a:endParaRPr lang="en-US" sz="1700" dirty="0"/>
-          </a:p>
-          <a:p>
-            <a:pPr marL="342900" indent="-342900">
-              <a:spcAft>
-                <a:spcPts val="800"/>
-              </a:spcAft>
-              <a:buSzPct val="100000"/>
-              <a:buChar char="•"/>
-            </a:pPr>
-            <a:r>
-              <a:rPr lang="en-US" sz="1700" dirty="0">
-                <a:solidFill>
-                  <a:srgbClr val="3B2A2A"/>
-                </a:solidFill>
-              </a:rPr>
-              <a:t>Escola precisa de quem decide não usar</a:t>
-            </a:r>
-            <a:endParaRPr lang="en-US" sz="1700" dirty="0"/>
-          </a:p>
-        </p:txBody>
-      </p:sp>
-      <p:sp>
-        <p:nvSpPr>
-          <p:cNvPr id="8" name="Shape 5"/>
+        </p:txBody>
+      </p:sp>
+      <p:sp>
+        <p:nvSpPr>
+          <p:cNvPr id="14" name="Shape 11"/>
           <p:cNvSpPr/>
           <p:nvPr/>
         </p:nvSpPr>
         <p:spPr>
           <a:xfrm>
-            <a:off x="6263640" y="1463040"/>
-            <a:ext cx="5394960" cy="4572000"/>
+            <a:off x="8107680" y="1463040"/>
+            <a:ext cx="3505200" cy="4480560"/>
           </a:xfrm>
           <a:prstGeom prst="roundRect">
             <a:avLst>
-              <a:gd name="adj" fmla="val 3000"/>
+              <a:gd name="adj" fmla="val 3913"/>
             </a:avLst>
           </a:prstGeom>
           <a:solidFill>
@@ -8828,23 +8898,28 @@
             </a:solidFill>
             <a:prstDash val="solid"/>
           </a:ln>
-        </p:spPr>
-      </p:sp>
-      <p:sp>
-        <p:nvSpPr>
-          <p:cNvPr id="9" name="Shape 6"/>
+          <a:effectLst>
+            <a:outerShdw sx="100000" sy="100000" kx="0" ky="0" algn="bl" rotWithShape="0" blurRad="76200" dist="25400" dir="5400000">
+              <a:srgbClr val="000000">
+                <a:alpha val="12000"/>
+              </a:srgbClr>
+            </a:outerShdw>
+          </a:effectLst>
+        </p:spPr>
+      </p:sp>
+      <p:sp>
+        <p:nvSpPr>
+          <p:cNvPr id="15" name="Shape 12"/>
           <p:cNvSpPr/>
           <p:nvPr/>
         </p:nvSpPr>
         <p:spPr>
           <a:xfrm>
-            <a:off x="6263640" y="1463040"/>
-            <a:ext cx="5394960" cy="731520"/>
-          </a:xfrm>
-          <a:prstGeom prst="roundRect">
-            <a:avLst>
-              <a:gd name="adj" fmla="val 18750"/>
-            </a:avLst>
+            <a:off x="8336280" y="1691640"/>
+            <a:ext cx="640080" cy="640080"/>
+          </a:xfrm>
+          <a:prstGeom prst="ellipse">
+            <a:avLst/>
           </a:prstGeom>
           <a:solidFill>
             <a:srgbClr val="6D3B6E"/>
@@ -8859,14 +8934,14 @@
       </p:sp>
       <p:sp>
         <p:nvSpPr>
-          <p:cNvPr id="10" name="Text 7"/>
-          <p:cNvSpPr txBox="1"/>
-          <p:nvPr/>
-        </p:nvSpPr>
-        <p:spPr>
-          <a:xfrm>
-            <a:off x="6492240" y="1463040"/>
-            <a:ext cx="4937760" cy="731520"/>
+          <p:cNvPr id="16" name="Text 13"/>
+          <p:cNvSpPr txBox="1"/>
+          <p:nvPr/>
+        </p:nvSpPr>
+        <p:spPr>
+          <a:xfrm>
+            <a:off x="8336280" y="1691640"/>
+            <a:ext cx="640080" cy="640080"/>
           </a:xfrm>
           <a:prstGeom prst="rect">
             <a:avLst/>
@@ -8878,11 +8953,11 @@
           <a:bodyPr wrap="square" lIns="0" tIns="0" rIns="0" bIns="0" rtlCol="0" anchor="ctr"/>
           <a:lstStyle/>
           <a:p>
-            <a:pPr indent="0" marL="0">
-              <a:buNone/>
-            </a:pPr>
-            <a:r>
-              <a:rPr lang="en-US" sz="2200" b="1" dirty="0">
+            <a:pPr algn="ctr" indent="0" marL="0">
+              <a:buNone/>
+            </a:pPr>
+            <a:r>
+              <a:rPr lang="en-US" sz="1600" b="1" dirty="0">
                 <a:solidFill>
                   <a:srgbClr val="FFFFFF"/>
                 </a:solidFill>
@@ -8890,22 +8965,22 @@
                 <a:ea typeface="Cambria" pitchFamily="34" charset="-122"/>
                 <a:cs typeface="Cambria" pitchFamily="34" charset="-120"/>
               </a:rPr>
-              <a:t>Falta de informação</a:t>
-            </a:r>
-            <a:endParaRPr lang="en-US" sz="2200" dirty="0"/>
-          </a:p>
-        </p:txBody>
-      </p:sp>
-      <p:sp>
-        <p:nvSpPr>
-          <p:cNvPr id="11" name="Text 8"/>
-          <p:cNvSpPr txBox="1"/>
-          <p:nvPr/>
-        </p:nvSpPr>
-        <p:spPr>
-          <a:xfrm>
-            <a:off x="6537960" y="2377440"/>
-            <a:ext cx="4846320" cy="3566160"/>
+              <a:t>3</a:t>
+            </a:r>
+            <a:endParaRPr lang="en-US" sz="1600" dirty="0"/>
+          </a:p>
+        </p:txBody>
+      </p:sp>
+      <p:sp>
+        <p:nvSpPr>
+          <p:cNvPr id="17" name="Text 14"/>
+          <p:cNvSpPr txBox="1"/>
+          <p:nvPr/>
+        </p:nvSpPr>
+        <p:spPr>
+          <a:xfrm>
+            <a:off x="8336280" y="2468880"/>
+            <a:ext cx="3048000" cy="822960"/>
           </a:xfrm>
           <a:prstGeom prst="rect">
             <a:avLst/>
@@ -8917,12 +8992,47 @@
           <a:bodyPr wrap="square" lIns="0" tIns="0" rIns="0" bIns="0" rtlCol="0" anchor="t"/>
           <a:lstStyle/>
           <a:p>
-            <a:pPr marL="342900" indent="-342900">
-              <a:spcAft>
-                <a:spcPts val="800"/>
-              </a:spcAft>
-              <a:buSzPct val="100000"/>
-              <a:buChar char="•"/>
+            <a:pPr indent="0" marL="0">
+              <a:buNone/>
+            </a:pPr>
+            <a:r>
+              <a:rPr lang="en-US" sz="2000" b="1" dirty="0">
+                <a:solidFill>
+                  <a:srgbClr val="5A2E2A"/>
+                </a:solidFill>
+                <a:latin typeface="Cambria" pitchFamily="34" charset="0"/>
+                <a:ea typeface="Cambria" pitchFamily="34" charset="-122"/>
+                <a:cs typeface="Cambria" pitchFamily="34" charset="-120"/>
+              </a:rPr>
+              <a:t>Acessibilidade e IA</a:t>
+            </a:r>
+            <a:endParaRPr lang="en-US" sz="2000" dirty="0"/>
+          </a:p>
+        </p:txBody>
+      </p:sp>
+      <p:sp>
+        <p:nvSpPr>
+          <p:cNvPr id="18" name="Text 15"/>
+          <p:cNvSpPr txBox="1"/>
+          <p:nvPr/>
+        </p:nvSpPr>
+        <p:spPr>
+          <a:xfrm>
+            <a:off x="8336280" y="3337560"/>
+            <a:ext cx="3048000" cy="2468880"/>
+          </a:xfrm>
+          <a:prstGeom prst="rect">
+            <a:avLst/>
+          </a:prstGeom>
+          <a:noFill/>
+          <a:ln/>
+        </p:spPr>
+        <p:txBody>
+          <a:bodyPr wrap="square" lIns="0" tIns="0" rIns="0" bIns="0" rtlCol="0" anchor="t"/>
+          <a:lstStyle/>
+          <a:p>
+            <a:pPr indent="0" marL="0">
+              <a:buNone/>
             </a:pPr>
             <a:r>
               <a:rPr lang="en-US" sz="1700" dirty="0">
@@ -8930,69 +9040,15 @@
                   <a:srgbClr val="3B2A2A"/>
                 </a:solidFill>
               </a:rPr>
-              <a:t>Resolve-se com estudo e prática</a:t>
+              <a:t>Desenho universal é consolidado; estudos controlados sobre IA ainda são escassos.</a:t>
             </a:r>
             <a:endParaRPr lang="en-US" sz="1700" dirty="0"/>
           </a:p>
-          <a:p>
-            <a:pPr marL="342900" indent="-342900">
-              <a:spcAft>
-                <a:spcPts val="800"/>
-              </a:spcAft>
-              <a:buSzPct val="100000"/>
-              <a:buChar char="•"/>
-            </a:pPr>
-            <a:r>
-              <a:rPr lang="en-US" sz="1700" dirty="0">
-                <a:solidFill>
-                  <a:srgbClr val="3B2A2A"/>
-                </a:solidFill>
-              </a:rPr>
-              <a:t>Convide para uma tentativa pequena</a:t>
-            </a:r>
-            <a:endParaRPr lang="en-US" sz="1700" dirty="0"/>
-          </a:p>
-          <a:p>
-            <a:pPr marL="342900" indent="-342900">
-              <a:spcAft>
-                <a:spcPts val="800"/>
-              </a:spcAft>
-              <a:buSzPct val="100000"/>
-              <a:buChar char="•"/>
-            </a:pPr>
-            <a:r>
-              <a:rPr lang="en-US" sz="1700" dirty="0">
-                <a:solidFill>
-                  <a:srgbClr val="3B2A2A"/>
-                </a:solidFill>
-              </a:rPr>
-              <a:t>Registre os resultados juntos</a:t>
-            </a:r>
-            <a:endParaRPr lang="en-US" sz="1700" dirty="0"/>
-          </a:p>
-          <a:p>
-            <a:pPr marL="342900" indent="-342900">
-              <a:spcAft>
-                <a:spcPts val="800"/>
-              </a:spcAft>
-              <a:buSzPct val="100000"/>
-              <a:buChar char="•"/>
-            </a:pPr>
-            <a:r>
-              <a:rPr lang="en-US" sz="1700" dirty="0">
-                <a:solidFill>
-                  <a:srgbClr val="3B2A2A"/>
-                </a:solidFill>
-              </a:rPr>
-              <a:t>Não imponha a adoção</a:t>
-            </a:r>
-            <a:endParaRPr lang="en-US" sz="1700" dirty="0"/>
-          </a:p>
-        </p:txBody>
-      </p:sp>
-      <p:sp>
-        <p:nvSpPr>
-          <p:cNvPr id="12" name="Text 9"/>
+        </p:txBody>
+      </p:sp>
+      <p:sp>
+        <p:nvSpPr>
+          <p:cNvPr id="19" name="Text 16"/>
           <p:cNvSpPr txBox="1"/>
           <p:nvPr/>
         </p:nvSpPr>
@@ -9839,7 +9895,7 @@
                 <a:ea typeface="Cambria" pitchFamily="34" charset="-122"/>
                 <a:cs typeface="Cambria" pitchFamily="34" charset="-120"/>
               </a:rPr>
-              <a:t>O que a pesquisa permite afirmar</a:t>
+              <a:t>Riscos e quando dispensar a IA</a:t>
             </a:r>
             <a:endParaRPr lang="en-US" sz="3400" dirty="0"/>
           </a:p>
@@ -9854,29 +9910,22 @@
         <p:spPr>
           <a:xfrm>
             <a:off x="548640" y="1463040"/>
-            <a:ext cx="3505200" cy="4480560"/>
+            <a:ext cx="11064240" cy="1051560"/>
           </a:xfrm>
           <a:prstGeom prst="roundRect">
             <a:avLst>
-              <a:gd name="adj" fmla="val 3913"/>
+              <a:gd name="adj" fmla="val 10435"/>
             </a:avLst>
           </a:prstGeom>
           <a:solidFill>
-            <a:srgbClr val="F7EFE6"/>
+            <a:srgbClr val="FDECE4"/>
           </a:solidFill>
           <a:ln w="12700">
             <a:solidFill>
-              <a:srgbClr val="F7EFE6"/>
+              <a:srgbClr val="F2B8A0"/>
             </a:solidFill>
             <a:prstDash val="solid"/>
           </a:ln>
-          <a:effectLst>
-            <a:outerShdw sx="100000" sy="100000" kx="0" ky="0" algn="bl" rotWithShape="0" blurRad="76200" dist="25400" dir="5400000">
-              <a:srgbClr val="000000">
-                <a:alpha val="12000"/>
-              </a:srgbClr>
-            </a:outerShdw>
-          </a:effectLst>
         </p:spPr>
       </p:sp>
       <p:sp>
@@ -9887,18 +9936,18 @@
         </p:nvSpPr>
         <p:spPr>
           <a:xfrm>
-            <a:off x="777240" y="1691640"/>
-            <a:ext cx="640080" cy="640080"/>
+            <a:off x="777240" y="1714500"/>
+            <a:ext cx="548640" cy="548640"/>
           </a:xfrm>
           <a:prstGeom prst="ellipse">
             <a:avLst/>
           </a:prstGeom>
           <a:solidFill>
-            <a:srgbClr val="6D3B6E"/>
+            <a:srgbClr val="C0392B"/>
           </a:solidFill>
           <a:ln w="12700">
             <a:solidFill>
-              <a:srgbClr val="6D3B6E"/>
+              <a:srgbClr val="C0392B"/>
             </a:solidFill>
             <a:prstDash val="solid"/>
           </a:ln>
@@ -9912,8 +9961,8 @@
         </p:nvSpPr>
         <p:spPr>
           <a:xfrm>
-            <a:off x="777240" y="1691640"/>
-            <a:ext cx="640080" cy="640080"/>
+            <a:off x="777240" y="1714500"/>
+            <a:ext cx="548640" cy="548640"/>
           </a:xfrm>
           <a:prstGeom prst="rect">
             <a:avLst/>
@@ -9929,17 +9978,14 @@
               <a:buNone/>
             </a:pPr>
             <a:r>
-              <a:rPr lang="en-US" sz="1600" b="1" dirty="0">
+              <a:rPr lang="en-US" sz="2200" b="1" dirty="0">
                 <a:solidFill>
                   <a:srgbClr val="FFFFFF"/>
                 </a:solidFill>
-                <a:latin typeface="Cambria" pitchFamily="34" charset="0"/>
-                <a:ea typeface="Cambria" pitchFamily="34" charset="-122"/>
-                <a:cs typeface="Cambria" pitchFamily="34" charset="-120"/>
-              </a:rPr>
-              <a:t>1</a:t>
-            </a:r>
-            <a:endParaRPr lang="en-US" sz="1600" dirty="0"/>
+              </a:rPr>
+              <a:t>!</a:t>
+            </a:r>
+            <a:endParaRPr lang="en-US" sz="2200" dirty="0"/>
           </a:p>
         </p:txBody>
       </p:sp>
@@ -9951,127 +9997,81 @@
         </p:nvSpPr>
         <p:spPr>
           <a:xfrm>
-            <a:off x="777240" y="2468880"/>
-            <a:ext cx="3048000" cy="822960"/>
-          </a:xfrm>
-          <a:prstGeom prst="rect">
-            <a:avLst/>
-          </a:prstGeom>
-          <a:noFill/>
-          <a:ln/>
-        </p:spPr>
-        <p:txBody>
-          <a:bodyPr wrap="square" lIns="0" tIns="0" rIns="0" bIns="0" rtlCol="0" anchor="t"/>
+            <a:off x="1600200" y="1463040"/>
+            <a:ext cx="9784080" cy="1051560"/>
+          </a:xfrm>
+          <a:prstGeom prst="rect">
+            <a:avLst/>
+          </a:prstGeom>
+          <a:noFill/>
+          <a:ln/>
+        </p:spPr>
+        <p:txBody>
+          <a:bodyPr wrap="square" lIns="0" tIns="0" rIns="0" bIns="0" rtlCol="0" anchor="ctr"/>
           <a:lstStyle/>
           <a:p>
             <a:pPr indent="0" marL="0">
               <a:buNone/>
             </a:pPr>
             <a:r>
-              <a:rPr lang="en-US" sz="2000" b="1" dirty="0">
-                <a:solidFill>
-                  <a:srgbClr val="5A2E2A"/>
-                </a:solidFill>
-                <a:latin typeface="Cambria" pitchFamily="34" charset="0"/>
-                <a:ea typeface="Cambria" pitchFamily="34" charset="-122"/>
-                <a:cs typeface="Cambria" pitchFamily="34" charset="-120"/>
-              </a:rPr>
-              <a:t>Formação docente</a:t>
-            </a:r>
-            <a:endParaRPr lang="en-US" sz="2000" dirty="0"/>
-          </a:p>
-        </p:txBody>
-      </p:sp>
-      <p:sp>
-        <p:nvSpPr>
-          <p:cNvPr id="8" name="Text 5"/>
-          <p:cNvSpPr txBox="1"/>
-          <p:nvPr/>
-        </p:nvSpPr>
-        <p:spPr>
-          <a:xfrm>
-            <a:off x="777240" y="3337560"/>
-            <a:ext cx="3048000" cy="2468880"/>
-          </a:xfrm>
-          <a:prstGeom prst="rect">
-            <a:avLst/>
-          </a:prstGeom>
-          <a:noFill/>
-          <a:ln/>
-        </p:spPr>
-        <p:txBody>
-          <a:bodyPr wrap="square" lIns="0" tIns="0" rIns="0" bIns="0" rtlCol="0" anchor="t"/>
-          <a:lstStyle/>
-          <a:p>
-            <a:pPr indent="0" marL="0">
-              <a:buNone/>
-            </a:pPr>
-            <a:r>
-              <a:rPr lang="en-US" sz="1700" dirty="0">
+              <a:rPr lang="en-US" sz="1800" dirty="0">
                 <a:solidFill>
                   <a:srgbClr val="3B2A2A"/>
                 </a:solidFill>
               </a:rPr>
-              <a:t>Ativa, colaborativa e sustentada se associa a mudança de prática, com variação.</a:t>
-            </a:r>
-            <a:endParaRPr lang="en-US" sz="1700" dirty="0"/>
-          </a:p>
-        </p:txBody>
-      </p:sp>
-      <p:sp>
-        <p:nvSpPr>
-          <p:cNvPr id="9" name="Shape 6"/>
+              <a:t>Adaptação errada: imagem mal descrita, fato alterado, legenda errada</a:t>
+            </a:r>
+            <a:endParaRPr lang="en-US" sz="1800" dirty="0"/>
+          </a:p>
+        </p:txBody>
+      </p:sp>
+      <p:sp>
+        <p:nvSpPr>
+          <p:cNvPr id="8" name="Shape 5"/>
           <p:cNvSpPr/>
           <p:nvPr/>
         </p:nvSpPr>
         <p:spPr>
           <a:xfrm>
-            <a:off x="4328160" y="1463040"/>
-            <a:ext cx="3505200" cy="4480560"/>
+            <a:off x="548640" y="2651760"/>
+            <a:ext cx="11064240" cy="1051560"/>
           </a:xfrm>
           <a:prstGeom prst="roundRect">
             <a:avLst>
-              <a:gd name="adj" fmla="val 3913"/>
+              <a:gd name="adj" fmla="val 10435"/>
             </a:avLst>
           </a:prstGeom>
           <a:solidFill>
-            <a:srgbClr val="F7EFE6"/>
+            <a:srgbClr val="FDECE4"/>
           </a:solidFill>
           <a:ln w="12700">
             <a:solidFill>
-              <a:srgbClr val="F7EFE6"/>
+              <a:srgbClr val="F2B8A0"/>
             </a:solidFill>
             <a:prstDash val="solid"/>
           </a:ln>
-          <a:effectLst>
-            <a:outerShdw sx="100000" sy="100000" kx="0" ky="0" algn="bl" rotWithShape="0" blurRad="76200" dist="25400" dir="5400000">
-              <a:srgbClr val="000000">
-                <a:alpha val="12000"/>
-              </a:srgbClr>
-            </a:outerShdw>
-          </a:effectLst>
-        </p:spPr>
-      </p:sp>
-      <p:sp>
-        <p:nvSpPr>
-          <p:cNvPr id="10" name="Shape 7"/>
+        </p:spPr>
+      </p:sp>
+      <p:sp>
+        <p:nvSpPr>
+          <p:cNvPr id="9" name="Shape 6"/>
           <p:cNvSpPr/>
           <p:nvPr/>
         </p:nvSpPr>
         <p:spPr>
           <a:xfrm>
-            <a:off x="4556760" y="1691640"/>
-            <a:ext cx="640080" cy="640080"/>
+            <a:off x="777240" y="2903220"/>
+            <a:ext cx="548640" cy="548640"/>
           </a:xfrm>
           <a:prstGeom prst="ellipse">
             <a:avLst/>
           </a:prstGeom>
           <a:solidFill>
-            <a:srgbClr val="2A9D8F"/>
+            <a:srgbClr val="C0392B"/>
           </a:solidFill>
           <a:ln w="12700">
             <a:solidFill>
-              <a:srgbClr val="2A9D8F"/>
+              <a:srgbClr val="C0392B"/>
             </a:solidFill>
             <a:prstDash val="solid"/>
           </a:ln>
@@ -10079,14 +10079,50 @@
       </p:sp>
       <p:sp>
         <p:nvSpPr>
+          <p:cNvPr id="10" name="Text 7"/>
+          <p:cNvSpPr txBox="1"/>
+          <p:nvPr/>
+        </p:nvSpPr>
+        <p:spPr>
+          <a:xfrm>
+            <a:off x="777240" y="2903220"/>
+            <a:ext cx="548640" cy="548640"/>
+          </a:xfrm>
+          <a:prstGeom prst="rect">
+            <a:avLst/>
+          </a:prstGeom>
+          <a:noFill/>
+          <a:ln/>
+        </p:spPr>
+        <p:txBody>
+          <a:bodyPr wrap="square" lIns="0" tIns="0" rIns="0" bIns="0" rtlCol="0" anchor="ctr"/>
+          <a:lstStyle/>
+          <a:p>
+            <a:pPr algn="ctr" indent="0" marL="0">
+              <a:buNone/>
+            </a:pPr>
+            <a:r>
+              <a:rPr lang="en-US" sz="2200" b="1" dirty="0">
+                <a:solidFill>
+                  <a:srgbClr val="FFFFFF"/>
+                </a:solidFill>
+              </a:rPr>
+              <a:t>!</a:t>
+            </a:r>
+            <a:endParaRPr lang="en-US" sz="2200" dirty="0"/>
+          </a:p>
+        </p:txBody>
+      </p:sp>
+      <p:sp>
+        <p:nvSpPr>
           <p:cNvPr id="11" name="Text 8"/>
           <p:cNvSpPr txBox="1"/>
           <p:nvPr/>
         </p:nvSpPr>
         <p:spPr>
           <a:xfrm>
-            <a:off x="4556760" y="1691640"/>
-            <a:ext cx="640080" cy="640080"/>
+            <a:off x="1600200" y="2651760"/>
+            <a:ext cx="9784080" cy="1051560"/>
           </a:xfrm>
           <a:prstGeom prst="rect">
             <a:avLst/>
@@ -10098,153 +10134,68 @@
           <a:bodyPr wrap="square" lIns="0" tIns="0" rIns="0" bIns="0" rtlCol="0" anchor="ctr"/>
           <a:lstStyle/>
           <a:p>
-            <a:pPr algn="ctr" indent="0" marL="0">
-              <a:buNone/>
-            </a:pPr>
-            <a:r>
-              <a:rPr lang="en-US" sz="1600" b="1" dirty="0">
-                <a:solidFill>
-                  <a:srgbClr val="FFFFFF"/>
-                </a:solidFill>
-                <a:latin typeface="Cambria" pitchFamily="34" charset="0"/>
-                <a:ea typeface="Cambria" pitchFamily="34" charset="-122"/>
-                <a:cs typeface="Cambria" pitchFamily="34" charset="-120"/>
-              </a:rPr>
-              <a:t>2</a:t>
-            </a:r>
-            <a:endParaRPr lang="en-US" sz="1600" dirty="0"/>
-          </a:p>
-        </p:txBody>
-      </p:sp>
-      <p:sp>
-        <p:nvSpPr>
-          <p:cNvPr id="12" name="Text 9"/>
-          <p:cNvSpPr txBox="1"/>
-          <p:nvPr/>
-        </p:nvSpPr>
-        <p:spPr>
-          <a:xfrm>
-            <a:off x="4556760" y="2468880"/>
-            <a:ext cx="3048000" cy="822960"/>
-          </a:xfrm>
-          <a:prstGeom prst="rect">
-            <a:avLst/>
-          </a:prstGeom>
-          <a:noFill/>
-          <a:ln/>
-        </p:spPr>
-        <p:txBody>
-          <a:bodyPr wrap="square" lIns="0" tIns="0" rIns="0" bIns="0" rtlCol="0" anchor="t"/>
-          <a:lstStyle/>
-          <a:p>
             <a:pPr indent="0" marL="0">
               <a:buNone/>
             </a:pPr>
             <a:r>
-              <a:rPr lang="en-US" sz="2000" b="1" dirty="0">
-                <a:solidFill>
-                  <a:srgbClr val="5A2E2A"/>
-                </a:solidFill>
-                <a:latin typeface="Cambria" pitchFamily="34" charset="0"/>
-                <a:ea typeface="Cambria" pitchFamily="34" charset="-122"/>
-                <a:cs typeface="Cambria" pitchFamily="34" charset="-120"/>
-              </a:rPr>
-              <a:t>Ganho de tempo</a:t>
-            </a:r>
-            <a:endParaRPr lang="en-US" sz="2000" dirty="0"/>
-          </a:p>
-        </p:txBody>
-      </p:sp>
-      <p:sp>
-        <p:nvSpPr>
-          <p:cNvPr id="13" name="Text 10"/>
-          <p:cNvSpPr txBox="1"/>
-          <p:nvPr/>
-        </p:nvSpPr>
-        <p:spPr>
-          <a:xfrm>
-            <a:off x="4556760" y="3337560"/>
-            <a:ext cx="3048000" cy="2468880"/>
-          </a:xfrm>
-          <a:prstGeom prst="rect">
-            <a:avLst/>
-          </a:prstGeom>
-          <a:noFill/>
-          <a:ln/>
-        </p:spPr>
-        <p:txBody>
-          <a:bodyPr wrap="square" lIns="0" tIns="0" rIns="0" bIns="0" rtlCol="0" anchor="t"/>
-          <a:lstStyle/>
-          <a:p>
-            <a:pPr indent="0" marL="0">
-              <a:buNone/>
-            </a:pPr>
-            <a:r>
-              <a:rPr lang="en-US" sz="1700" dirty="0">
+              <a:rPr lang="en-US" sz="1800" dirty="0">
                 <a:solidFill>
                   <a:srgbClr val="3B2A2A"/>
                 </a:solidFill>
               </a:rPr>
-              <a:t>Poucas evidências robustas para professores brasileiros; depende da tarefa.</a:t>
-            </a:r>
-            <a:endParaRPr lang="en-US" sz="1700" dirty="0"/>
-          </a:p>
-        </p:txBody>
-      </p:sp>
-      <p:sp>
-        <p:nvSpPr>
-          <p:cNvPr id="14" name="Shape 11"/>
+              <a:t>Estigma: material diferente que marca o estudante</a:t>
+            </a:r>
+            <a:endParaRPr lang="en-US" sz="1800" dirty="0"/>
+          </a:p>
+        </p:txBody>
+      </p:sp>
+      <p:sp>
+        <p:nvSpPr>
+          <p:cNvPr id="12" name="Shape 9"/>
           <p:cNvSpPr/>
           <p:nvPr/>
         </p:nvSpPr>
         <p:spPr>
           <a:xfrm>
-            <a:off x="8107680" y="1463040"/>
-            <a:ext cx="3505200" cy="4480560"/>
+            <a:off x="548640" y="3840480"/>
+            <a:ext cx="11064240" cy="1051560"/>
           </a:xfrm>
           <a:prstGeom prst="roundRect">
             <a:avLst>
-              <a:gd name="adj" fmla="val 3913"/>
+              <a:gd name="adj" fmla="val 10435"/>
             </a:avLst>
           </a:prstGeom>
           <a:solidFill>
-            <a:srgbClr val="F7EFE6"/>
+            <a:srgbClr val="FDECE4"/>
           </a:solidFill>
           <a:ln w="12700">
             <a:solidFill>
-              <a:srgbClr val="F7EFE6"/>
+              <a:srgbClr val="F2B8A0"/>
             </a:solidFill>
             <a:prstDash val="solid"/>
           </a:ln>
-          <a:effectLst>
-            <a:outerShdw sx="100000" sy="100000" kx="0" ky="0" algn="bl" rotWithShape="0" blurRad="76200" dist="25400" dir="5400000">
-              <a:srgbClr val="000000">
-                <a:alpha val="12000"/>
-              </a:srgbClr>
-            </a:outerShdw>
-          </a:effectLst>
-        </p:spPr>
-      </p:sp>
-      <p:sp>
-        <p:nvSpPr>
-          <p:cNvPr id="15" name="Shape 12"/>
+        </p:spPr>
+      </p:sp>
+      <p:sp>
+        <p:nvSpPr>
+          <p:cNvPr id="13" name="Shape 10"/>
           <p:cNvSpPr/>
           <p:nvPr/>
         </p:nvSpPr>
         <p:spPr>
           <a:xfrm>
-            <a:off x="8336280" y="1691640"/>
-            <a:ext cx="640080" cy="640080"/>
+            <a:off x="777240" y="4091940"/>
+            <a:ext cx="548640" cy="548640"/>
           </a:xfrm>
           <a:prstGeom prst="ellipse">
             <a:avLst/>
           </a:prstGeom>
           <a:solidFill>
-            <a:srgbClr val="6D3B6E"/>
+            <a:srgbClr val="C0392B"/>
           </a:solidFill>
           <a:ln w="12700">
             <a:solidFill>
-              <a:srgbClr val="6D3B6E"/>
+              <a:srgbClr val="C0392B"/>
             </a:solidFill>
             <a:prstDash val="solid"/>
           </a:ln>
@@ -10252,14 +10203,14 @@
       </p:sp>
       <p:sp>
         <p:nvSpPr>
-          <p:cNvPr id="16" name="Text 13"/>
-          <p:cNvSpPr txBox="1"/>
-          <p:nvPr/>
-        </p:nvSpPr>
-        <p:spPr>
-          <a:xfrm>
-            <a:off x="8336280" y="1691640"/>
-            <a:ext cx="640080" cy="640080"/>
+          <p:cNvPr id="14" name="Text 11"/>
+          <p:cNvSpPr txBox="1"/>
+          <p:nvPr/>
+        </p:nvSpPr>
+        <p:spPr>
+          <a:xfrm>
+            <a:off x="777240" y="4091940"/>
+            <a:ext cx="548640" cy="548640"/>
           </a:xfrm>
           <a:prstGeom prst="rect">
             <a:avLst/>
@@ -10275,58 +10226,104 @@
               <a:buNone/>
             </a:pPr>
             <a:r>
-              <a:rPr lang="en-US" sz="1600" b="1" dirty="0">
+              <a:rPr lang="en-US" sz="2200" b="1" dirty="0">
                 <a:solidFill>
                   <a:srgbClr val="FFFFFF"/>
                 </a:solidFill>
-                <a:latin typeface="Cambria" pitchFamily="34" charset="0"/>
-                <a:ea typeface="Cambria" pitchFamily="34" charset="-122"/>
-                <a:cs typeface="Cambria" pitchFamily="34" charset="-120"/>
-              </a:rPr>
-              <a:t>3</a:t>
-            </a:r>
-            <a:endParaRPr lang="en-US" sz="1600" dirty="0"/>
-          </a:p>
-        </p:txBody>
-      </p:sp>
-      <p:sp>
-        <p:nvSpPr>
-          <p:cNvPr id="17" name="Text 14"/>
-          <p:cNvSpPr txBox="1"/>
-          <p:nvPr/>
-        </p:nvSpPr>
-        <p:spPr>
-          <a:xfrm>
-            <a:off x="8336280" y="2468880"/>
-            <a:ext cx="3048000" cy="822960"/>
-          </a:xfrm>
-          <a:prstGeom prst="rect">
-            <a:avLst/>
-          </a:prstGeom>
-          <a:noFill/>
-          <a:ln/>
-        </p:spPr>
-        <p:txBody>
-          <a:bodyPr wrap="square" lIns="0" tIns="0" rIns="0" bIns="0" rtlCol="0" anchor="t"/>
+              </a:rPr>
+              <a:t>!</a:t>
+            </a:r>
+            <a:endParaRPr lang="en-US" sz="2200" dirty="0"/>
+          </a:p>
+        </p:txBody>
+      </p:sp>
+      <p:sp>
+        <p:nvSpPr>
+          <p:cNvPr id="15" name="Text 12"/>
+          <p:cNvSpPr txBox="1"/>
+          <p:nvPr/>
+        </p:nvSpPr>
+        <p:spPr>
+          <a:xfrm>
+            <a:off x="1600200" y="3840480"/>
+            <a:ext cx="9784080" cy="1051560"/>
+          </a:xfrm>
+          <a:prstGeom prst="rect">
+            <a:avLst/>
+          </a:prstGeom>
+          <a:noFill/>
+          <a:ln/>
+        </p:spPr>
+        <p:txBody>
+          <a:bodyPr wrap="square" lIns="0" tIns="0" rIns="0" bIns="0" rtlCol="0" anchor="ctr"/>
           <a:lstStyle/>
           <a:p>
             <a:pPr indent="0" marL="0">
               <a:buNone/>
             </a:pPr>
             <a:r>
-              <a:rPr lang="en-US" sz="2000" b="1" dirty="0">
-                <a:solidFill>
-                  <a:srgbClr val="5A2E2A"/>
-                </a:solidFill>
-                <a:latin typeface="Cambria" pitchFamily="34" charset="0"/>
-                <a:ea typeface="Cambria" pitchFamily="34" charset="-122"/>
-                <a:cs typeface="Cambria" pitchFamily="34" charset="-120"/>
-              </a:rPr>
-              <a:t>Acessibilidade e IA</a:t>
-            </a:r>
-            <a:endParaRPr lang="en-US" sz="2000" dirty="0"/>
-          </a:p>
-        </p:txBody>
+              <a:rPr lang="en-US" sz="1800" dirty="0">
+                <a:solidFill>
+                  <a:srgbClr val="3B2A2A"/>
+                </a:solidFill>
+              </a:rPr>
+              <a:t>Dispense se o pedido exigir dados ou laudos identificáveis</a:t>
+            </a:r>
+            <a:endParaRPr lang="en-US" sz="1800" dirty="0"/>
+          </a:p>
+        </p:txBody>
+      </p:sp>
+      <p:sp>
+        <p:nvSpPr>
+          <p:cNvPr id="16" name="Shape 13"/>
+          <p:cNvSpPr/>
+          <p:nvPr/>
+        </p:nvSpPr>
+        <p:spPr>
+          <a:xfrm>
+            <a:off x="548640" y="5029200"/>
+            <a:ext cx="11064240" cy="1051560"/>
+          </a:xfrm>
+          <a:prstGeom prst="roundRect">
+            <a:avLst>
+              <a:gd name="adj" fmla="val 10435"/>
+            </a:avLst>
+          </a:prstGeom>
+          <a:solidFill>
+            <a:srgbClr val="FDECE4"/>
+          </a:solidFill>
+          <a:ln w="12700">
+            <a:solidFill>
+              <a:srgbClr val="F2B8A0"/>
+            </a:solidFill>
+            <a:prstDash val="solid"/>
+          </a:ln>
+        </p:spPr>
+      </p:sp>
+      <p:sp>
+        <p:nvSpPr>
+          <p:cNvPr id="17" name="Shape 14"/>
+          <p:cNvSpPr/>
+          <p:nvPr/>
+        </p:nvSpPr>
+        <p:spPr>
+          <a:xfrm>
+            <a:off x="777240" y="5280660"/>
+            <a:ext cx="548640" cy="548640"/>
+          </a:xfrm>
+          <a:prstGeom prst="ellipse">
+            <a:avLst/>
+          </a:prstGeom>
+          <a:solidFill>
+            <a:srgbClr val="C0392B"/>
+          </a:solidFill>
+          <a:ln w="12700">
+            <a:solidFill>
+              <a:srgbClr val="C0392B"/>
+            </a:solidFill>
+            <a:prstDash val="solid"/>
+          </a:ln>
+        </p:spPr>
       </p:sp>
       <p:sp>
         <p:nvSpPr>
@@ -10336,37 +10333,73 @@
         </p:nvSpPr>
         <p:spPr>
           <a:xfrm>
-            <a:off x="8336280" y="3337560"/>
-            <a:ext cx="3048000" cy="2468880"/>
-          </a:xfrm>
-          <a:prstGeom prst="rect">
-            <a:avLst/>
-          </a:prstGeom>
-          <a:noFill/>
-          <a:ln/>
-        </p:spPr>
-        <p:txBody>
-          <a:bodyPr wrap="square" lIns="0" tIns="0" rIns="0" bIns="0" rtlCol="0" anchor="t"/>
+            <a:off x="777240" y="5280660"/>
+            <a:ext cx="548640" cy="548640"/>
+          </a:xfrm>
+          <a:prstGeom prst="rect">
+            <a:avLst/>
+          </a:prstGeom>
+          <a:noFill/>
+          <a:ln/>
+        </p:spPr>
+        <p:txBody>
+          <a:bodyPr wrap="square" lIns="0" tIns="0" rIns="0" bIns="0" rtlCol="0" anchor="ctr"/>
+          <a:lstStyle/>
+          <a:p>
+            <a:pPr algn="ctr" indent="0" marL="0">
+              <a:buNone/>
+            </a:pPr>
+            <a:r>
+              <a:rPr lang="en-US" sz="2200" b="1" dirty="0">
+                <a:solidFill>
+                  <a:srgbClr val="FFFFFF"/>
+                </a:solidFill>
+              </a:rPr>
+              <a:t>!</a:t>
+            </a:r>
+            <a:endParaRPr lang="en-US" sz="2200" dirty="0"/>
+          </a:p>
+        </p:txBody>
+      </p:sp>
+      <p:sp>
+        <p:nvSpPr>
+          <p:cNvPr id="19" name="Text 16"/>
+          <p:cNvSpPr txBox="1"/>
+          <p:nvPr/>
+        </p:nvSpPr>
+        <p:spPr>
+          <a:xfrm>
+            <a:off x="1600200" y="5029200"/>
+            <a:ext cx="9784080" cy="1051560"/>
+          </a:xfrm>
+          <a:prstGeom prst="rect">
+            <a:avLst/>
+          </a:prstGeom>
+          <a:noFill/>
+          <a:ln/>
+        </p:spPr>
+        <p:txBody>
+          <a:bodyPr wrap="square" lIns="0" tIns="0" rIns="0" bIns="0" rtlCol="0" anchor="ctr"/>
           <a:lstStyle/>
           <a:p>
             <a:pPr indent="0" marL="0">
               <a:buNone/>
             </a:pPr>
             <a:r>
-              <a:rPr lang="en-US" sz="1700" dirty="0">
+              <a:rPr lang="en-US" sz="1800" dirty="0">
                 <a:solidFill>
                   <a:srgbClr val="3B2A2A"/>
                 </a:solidFill>
               </a:rPr>
-              <a:t>Desenho universal é consolidado; estudos controlados sobre IA ainda são escassos.</a:t>
-            </a:r>
-            <a:endParaRPr lang="en-US" sz="1700" dirty="0"/>
-          </a:p>
-        </p:txBody>
-      </p:sp>
-      <p:sp>
-        <p:nvSpPr>
-          <p:cNvPr id="19" name="Text 16"/>
+              <a:t>Dispense em material crítico de segurança ou saúde, ou sem como verificar</a:t>
+            </a:r>
+            <a:endParaRPr lang="en-US" sz="1800" dirty="0"/>
+          </a:p>
+        </p:txBody>
+      </p:sp>
+      <p:sp>
+        <p:nvSpPr>
+          <p:cNvPr id="20" name="Text 17"/>
           <p:cNvSpPr txBox="1"/>
           <p:nvPr/>
         </p:nvSpPr>
@@ -10468,74 +10501,46 @@
                 <a:ea typeface="Cambria" pitchFamily="34" charset="-122"/>
                 <a:cs typeface="Cambria" pitchFamily="34" charset="-120"/>
               </a:rPr>
-              <a:t>Riscos e quando dispensar a IA</a:t>
+              <a:t>Síntese: apoio entre estudantes, professores e colegas</a:t>
             </a:r>
             <a:endParaRPr lang="en-US" sz="3400" dirty="0"/>
           </a:p>
         </p:txBody>
       </p:sp>
-      <p:sp>
-        <p:nvSpPr>
-          <p:cNvPr id="4" name="Shape 1"/>
-          <p:cNvSpPr/>
-          <p:nvPr/>
-        </p:nvSpPr>
-        <p:spPr>
-          <a:xfrm>
-            <a:off x="548640" y="1463040"/>
-            <a:ext cx="11064240" cy="1051560"/>
-          </a:xfrm>
-          <a:prstGeom prst="roundRect">
-            <a:avLst>
-              <a:gd name="adj" fmla="val 10435"/>
-            </a:avLst>
-          </a:prstGeom>
-          <a:solidFill>
-            <a:srgbClr val="FDECE4"/>
-          </a:solidFill>
-          <a:ln w="12700">
-            <a:solidFill>
-              <a:srgbClr val="F2B8A0"/>
-            </a:solidFill>
-            <a:prstDash val="solid"/>
-          </a:ln>
-        </p:spPr>
-      </p:sp>
-      <p:sp>
-        <p:nvSpPr>
-          <p:cNvPr id="5" name="Shape 2"/>
-          <p:cNvSpPr/>
-          <p:nvPr/>
-        </p:nvSpPr>
-        <p:spPr>
-          <a:xfrm>
-            <a:off x="777240" y="1714500"/>
-            <a:ext cx="548640" cy="548640"/>
-          </a:xfrm>
-          <a:prstGeom prst="ellipse">
-            <a:avLst/>
-          </a:prstGeom>
-          <a:solidFill>
-            <a:srgbClr val="C0392B"/>
-          </a:solidFill>
-          <a:ln w="12700">
-            <a:solidFill>
-              <a:srgbClr val="C0392B"/>
-            </a:solidFill>
-            <a:prstDash val="solid"/>
-          </a:ln>
-        </p:spPr>
-      </p:sp>
-      <p:sp>
-        <p:nvSpPr>
-          <p:cNvPr id="6" name="Text 3"/>
-          <p:cNvSpPr txBox="1"/>
-          <p:nvPr/>
-        </p:nvSpPr>
-        <p:spPr>
-          <a:xfrm>
-            <a:off x="777240" y="1714500"/>
-            <a:ext cx="548640" cy="548640"/>
+      <p:pic>
+        <p:nvPicPr>
+          <p:cNvPr id="4" name="Image 0" descr="Figura 23.4 — Acessibilidade, trabalho e formação, com a IA como ferramenta.">    </p:cNvPr>
+          <p:cNvPicPr>
+            <a:picLocks noChangeAspect="1"/>
+          </p:cNvPicPr>
+          <p:nvPr/>
+        </p:nvPicPr>
+        <p:blipFill>
+          <a:blip r:embed="rId1"/>
+          <a:stretch>
+            <a:fillRect/>
+          </a:stretch>
+        </p:blipFill>
+        <p:spPr>
+          <a:xfrm>
+            <a:off x="1856957" y="1325880"/>
+            <a:ext cx="8447606" cy="4434840"/>
+          </a:xfrm>
+          <a:prstGeom prst="rect">
+            <a:avLst/>
+          </a:prstGeom>
+        </p:spPr>
+      </p:pic>
+      <p:sp>
+        <p:nvSpPr>
+          <p:cNvPr id="5" name="Text 1"/>
+          <p:cNvSpPr txBox="1"/>
+          <p:nvPr/>
+        </p:nvSpPr>
+        <p:spPr>
+          <a:xfrm>
+            <a:off x="548640" y="5852160"/>
+            <a:ext cx="11064240" cy="548640"/>
           </a:xfrm>
           <a:prstGeom prst="rect">
             <a:avLst/>
@@ -10551,428 +10556,20 @@
               <a:buNone/>
             </a:pPr>
             <a:r>
-              <a:rPr lang="en-US" sz="2200" b="1" dirty="0">
-                <a:solidFill>
-                  <a:srgbClr val="FFFFFF"/>
-                </a:solidFill>
-              </a:rPr>
-              <a:t>!</a:t>
-            </a:r>
-            <a:endParaRPr lang="en-US" sz="2200" dirty="0"/>
-          </a:p>
-        </p:txBody>
-      </p:sp>
-      <p:sp>
-        <p:nvSpPr>
-          <p:cNvPr id="7" name="Text 4"/>
-          <p:cNvSpPr txBox="1"/>
-          <p:nvPr/>
-        </p:nvSpPr>
-        <p:spPr>
-          <a:xfrm>
-            <a:off x="1600200" y="1463040"/>
-            <a:ext cx="9784080" cy="1051560"/>
-          </a:xfrm>
-          <a:prstGeom prst="rect">
-            <a:avLst/>
-          </a:prstGeom>
-          <a:noFill/>
-          <a:ln/>
-        </p:spPr>
-        <p:txBody>
-          <a:bodyPr wrap="square" lIns="0" tIns="0" rIns="0" bIns="0" rtlCol="0" anchor="ctr"/>
-          <a:lstStyle/>
-          <a:p>
-            <a:pPr indent="0" marL="0">
-              <a:buNone/>
-            </a:pPr>
-            <a:r>
-              <a:rPr lang="en-US" sz="1800" dirty="0">
-                <a:solidFill>
-                  <a:srgbClr val="3B2A2A"/>
-                </a:solidFill>
-              </a:rPr>
-              <a:t>Adaptação errada: imagem mal descrita, fato alterado, legenda errada</a:t>
-            </a:r>
-            <a:endParaRPr lang="en-US" sz="1800" dirty="0"/>
-          </a:p>
-        </p:txBody>
-      </p:sp>
-      <p:sp>
-        <p:nvSpPr>
-          <p:cNvPr id="8" name="Shape 5"/>
-          <p:cNvSpPr/>
-          <p:nvPr/>
-        </p:nvSpPr>
-        <p:spPr>
-          <a:xfrm>
-            <a:off x="548640" y="2651760"/>
-            <a:ext cx="11064240" cy="1051560"/>
-          </a:xfrm>
-          <a:prstGeom prst="roundRect">
-            <a:avLst>
-              <a:gd name="adj" fmla="val 10435"/>
-            </a:avLst>
-          </a:prstGeom>
-          <a:solidFill>
-            <a:srgbClr val="FDECE4"/>
-          </a:solidFill>
-          <a:ln w="12700">
-            <a:solidFill>
-              <a:srgbClr val="F2B8A0"/>
-            </a:solidFill>
-            <a:prstDash val="solid"/>
-          </a:ln>
-        </p:spPr>
-      </p:sp>
-      <p:sp>
-        <p:nvSpPr>
-          <p:cNvPr id="9" name="Shape 6"/>
-          <p:cNvSpPr/>
-          <p:nvPr/>
-        </p:nvSpPr>
-        <p:spPr>
-          <a:xfrm>
-            <a:off x="777240" y="2903220"/>
-            <a:ext cx="548640" cy="548640"/>
-          </a:xfrm>
-          <a:prstGeom prst="ellipse">
-            <a:avLst/>
-          </a:prstGeom>
-          <a:solidFill>
-            <a:srgbClr val="C0392B"/>
-          </a:solidFill>
-          <a:ln w="12700">
-            <a:solidFill>
-              <a:srgbClr val="C0392B"/>
-            </a:solidFill>
-            <a:prstDash val="solid"/>
-          </a:ln>
-        </p:spPr>
-      </p:sp>
-      <p:sp>
-        <p:nvSpPr>
-          <p:cNvPr id="10" name="Text 7"/>
-          <p:cNvSpPr txBox="1"/>
-          <p:nvPr/>
-        </p:nvSpPr>
-        <p:spPr>
-          <a:xfrm>
-            <a:off x="777240" y="2903220"/>
-            <a:ext cx="548640" cy="548640"/>
-          </a:xfrm>
-          <a:prstGeom prst="rect">
-            <a:avLst/>
-          </a:prstGeom>
-          <a:noFill/>
-          <a:ln/>
-        </p:spPr>
-        <p:txBody>
-          <a:bodyPr wrap="square" lIns="0" tIns="0" rIns="0" bIns="0" rtlCol="0" anchor="ctr"/>
-          <a:lstStyle/>
-          <a:p>
-            <a:pPr algn="ctr" indent="0" marL="0">
-              <a:buNone/>
-            </a:pPr>
-            <a:r>
-              <a:rPr lang="en-US" sz="2200" b="1" dirty="0">
-                <a:solidFill>
-                  <a:srgbClr val="FFFFFF"/>
-                </a:solidFill>
-              </a:rPr>
-              <a:t>!</a:t>
-            </a:r>
-            <a:endParaRPr lang="en-US" sz="2200" dirty="0"/>
-          </a:p>
-        </p:txBody>
-      </p:sp>
-      <p:sp>
-        <p:nvSpPr>
-          <p:cNvPr id="11" name="Text 8"/>
-          <p:cNvSpPr txBox="1"/>
-          <p:nvPr/>
-        </p:nvSpPr>
-        <p:spPr>
-          <a:xfrm>
-            <a:off x="1600200" y="2651760"/>
-            <a:ext cx="9784080" cy="1051560"/>
-          </a:xfrm>
-          <a:prstGeom prst="rect">
-            <a:avLst/>
-          </a:prstGeom>
-          <a:noFill/>
-          <a:ln/>
-        </p:spPr>
-        <p:txBody>
-          <a:bodyPr wrap="square" lIns="0" tIns="0" rIns="0" bIns="0" rtlCol="0" anchor="ctr"/>
-          <a:lstStyle/>
-          <a:p>
-            <a:pPr indent="0" marL="0">
-              <a:buNone/>
-            </a:pPr>
-            <a:r>
-              <a:rPr lang="en-US" sz="1800" dirty="0">
-                <a:solidFill>
-                  <a:srgbClr val="3B2A2A"/>
-                </a:solidFill>
-              </a:rPr>
-              <a:t>Estigma: material diferente que marca o estudante</a:t>
-            </a:r>
-            <a:endParaRPr lang="en-US" sz="1800" dirty="0"/>
-          </a:p>
-        </p:txBody>
-      </p:sp>
-      <p:sp>
-        <p:nvSpPr>
-          <p:cNvPr id="12" name="Shape 9"/>
-          <p:cNvSpPr/>
-          <p:nvPr/>
-        </p:nvSpPr>
-        <p:spPr>
-          <a:xfrm>
-            <a:off x="548640" y="3840480"/>
-            <a:ext cx="11064240" cy="1051560"/>
-          </a:xfrm>
-          <a:prstGeom prst="roundRect">
-            <a:avLst>
-              <a:gd name="adj" fmla="val 10435"/>
-            </a:avLst>
-          </a:prstGeom>
-          <a:solidFill>
-            <a:srgbClr val="FDECE4"/>
-          </a:solidFill>
-          <a:ln w="12700">
-            <a:solidFill>
-              <a:srgbClr val="F2B8A0"/>
-            </a:solidFill>
-            <a:prstDash val="solid"/>
-          </a:ln>
-        </p:spPr>
-      </p:sp>
-      <p:sp>
-        <p:nvSpPr>
-          <p:cNvPr id="13" name="Shape 10"/>
-          <p:cNvSpPr/>
-          <p:nvPr/>
-        </p:nvSpPr>
-        <p:spPr>
-          <a:xfrm>
-            <a:off x="777240" y="4091940"/>
-            <a:ext cx="548640" cy="548640"/>
-          </a:xfrm>
-          <a:prstGeom prst="ellipse">
-            <a:avLst/>
-          </a:prstGeom>
-          <a:solidFill>
-            <a:srgbClr val="C0392B"/>
-          </a:solidFill>
-          <a:ln w="12700">
-            <a:solidFill>
-              <a:srgbClr val="C0392B"/>
-            </a:solidFill>
-            <a:prstDash val="solid"/>
-          </a:ln>
-        </p:spPr>
-      </p:sp>
-      <p:sp>
-        <p:nvSpPr>
-          <p:cNvPr id="14" name="Text 11"/>
-          <p:cNvSpPr txBox="1"/>
-          <p:nvPr/>
-        </p:nvSpPr>
-        <p:spPr>
-          <a:xfrm>
-            <a:off x="777240" y="4091940"/>
-            <a:ext cx="548640" cy="548640"/>
-          </a:xfrm>
-          <a:prstGeom prst="rect">
-            <a:avLst/>
-          </a:prstGeom>
-          <a:noFill/>
-          <a:ln/>
-        </p:spPr>
-        <p:txBody>
-          <a:bodyPr wrap="square" lIns="0" tIns="0" rIns="0" bIns="0" rtlCol="0" anchor="ctr"/>
-          <a:lstStyle/>
-          <a:p>
-            <a:pPr algn="ctr" indent="0" marL="0">
-              <a:buNone/>
-            </a:pPr>
-            <a:r>
-              <a:rPr lang="en-US" sz="2200" b="1" dirty="0">
-                <a:solidFill>
-                  <a:srgbClr val="FFFFFF"/>
-                </a:solidFill>
-              </a:rPr>
-              <a:t>!</a:t>
-            </a:r>
-            <a:endParaRPr lang="en-US" sz="2200" dirty="0"/>
-          </a:p>
-        </p:txBody>
-      </p:sp>
-      <p:sp>
-        <p:nvSpPr>
-          <p:cNvPr id="15" name="Text 12"/>
-          <p:cNvSpPr txBox="1"/>
-          <p:nvPr/>
-        </p:nvSpPr>
-        <p:spPr>
-          <a:xfrm>
-            <a:off x="1600200" y="3840480"/>
-            <a:ext cx="9784080" cy="1051560"/>
-          </a:xfrm>
-          <a:prstGeom prst="rect">
-            <a:avLst/>
-          </a:prstGeom>
-          <a:noFill/>
-          <a:ln/>
-        </p:spPr>
-        <p:txBody>
-          <a:bodyPr wrap="square" lIns="0" tIns="0" rIns="0" bIns="0" rtlCol="0" anchor="ctr"/>
-          <a:lstStyle/>
-          <a:p>
-            <a:pPr indent="0" marL="0">
-              <a:buNone/>
-            </a:pPr>
-            <a:r>
-              <a:rPr lang="en-US" sz="1800" dirty="0">
-                <a:solidFill>
-                  <a:srgbClr val="3B2A2A"/>
-                </a:solidFill>
-              </a:rPr>
-              <a:t>Dispense se o pedido exigir dados ou laudos identificáveis</a:t>
-            </a:r>
-            <a:endParaRPr lang="en-US" sz="1800" dirty="0"/>
-          </a:p>
-        </p:txBody>
-      </p:sp>
-      <p:sp>
-        <p:nvSpPr>
-          <p:cNvPr id="16" name="Shape 13"/>
-          <p:cNvSpPr/>
-          <p:nvPr/>
-        </p:nvSpPr>
-        <p:spPr>
-          <a:xfrm>
-            <a:off x="548640" y="5029200"/>
-            <a:ext cx="11064240" cy="1051560"/>
-          </a:xfrm>
-          <a:prstGeom prst="roundRect">
-            <a:avLst>
-              <a:gd name="adj" fmla="val 10435"/>
-            </a:avLst>
-          </a:prstGeom>
-          <a:solidFill>
-            <a:srgbClr val="FDECE4"/>
-          </a:solidFill>
-          <a:ln w="12700">
-            <a:solidFill>
-              <a:srgbClr val="F2B8A0"/>
-            </a:solidFill>
-            <a:prstDash val="solid"/>
-          </a:ln>
-        </p:spPr>
-      </p:sp>
-      <p:sp>
-        <p:nvSpPr>
-          <p:cNvPr id="17" name="Shape 14"/>
-          <p:cNvSpPr/>
-          <p:nvPr/>
-        </p:nvSpPr>
-        <p:spPr>
-          <a:xfrm>
-            <a:off x="777240" y="5280660"/>
-            <a:ext cx="548640" cy="548640"/>
-          </a:xfrm>
-          <a:prstGeom prst="ellipse">
-            <a:avLst/>
-          </a:prstGeom>
-          <a:solidFill>
-            <a:srgbClr val="C0392B"/>
-          </a:solidFill>
-          <a:ln w="12700">
-            <a:solidFill>
-              <a:srgbClr val="C0392B"/>
-            </a:solidFill>
-            <a:prstDash val="solid"/>
-          </a:ln>
-        </p:spPr>
-      </p:sp>
-      <p:sp>
-        <p:nvSpPr>
-          <p:cNvPr id="18" name="Text 15"/>
-          <p:cNvSpPr txBox="1"/>
-          <p:nvPr/>
-        </p:nvSpPr>
-        <p:spPr>
-          <a:xfrm>
-            <a:off x="777240" y="5280660"/>
-            <a:ext cx="548640" cy="548640"/>
-          </a:xfrm>
-          <a:prstGeom prst="rect">
-            <a:avLst/>
-          </a:prstGeom>
-          <a:noFill/>
-          <a:ln/>
-        </p:spPr>
-        <p:txBody>
-          <a:bodyPr wrap="square" lIns="0" tIns="0" rIns="0" bIns="0" rtlCol="0" anchor="ctr"/>
-          <a:lstStyle/>
-          <a:p>
-            <a:pPr algn="ctr" indent="0" marL="0">
-              <a:buNone/>
-            </a:pPr>
-            <a:r>
-              <a:rPr lang="en-US" sz="2200" b="1" dirty="0">
-                <a:solidFill>
-                  <a:srgbClr val="FFFFFF"/>
-                </a:solidFill>
-              </a:rPr>
-              <a:t>!</a:t>
-            </a:r>
-            <a:endParaRPr lang="en-US" sz="2200" dirty="0"/>
-          </a:p>
-        </p:txBody>
-      </p:sp>
-      <p:sp>
-        <p:nvSpPr>
-          <p:cNvPr id="19" name="Text 16"/>
-          <p:cNvSpPr txBox="1"/>
-          <p:nvPr/>
-        </p:nvSpPr>
-        <p:spPr>
-          <a:xfrm>
-            <a:off x="1600200" y="5029200"/>
-            <a:ext cx="9784080" cy="1051560"/>
-          </a:xfrm>
-          <a:prstGeom prst="rect">
-            <a:avLst/>
-          </a:prstGeom>
-          <a:noFill/>
-          <a:ln/>
-        </p:spPr>
-        <p:txBody>
-          <a:bodyPr wrap="square" lIns="0" tIns="0" rIns="0" bIns="0" rtlCol="0" anchor="ctr"/>
-          <a:lstStyle/>
-          <a:p>
-            <a:pPr indent="0" marL="0">
-              <a:buNone/>
-            </a:pPr>
-            <a:r>
-              <a:rPr lang="en-US" sz="1800" dirty="0">
-                <a:solidFill>
-                  <a:srgbClr val="3B2A2A"/>
-                </a:solidFill>
-              </a:rPr>
-              <a:t>Dispense em material crítico de segurança ou saúde, ou sem como verificar</a:t>
-            </a:r>
-            <a:endParaRPr lang="en-US" sz="1800" dirty="0"/>
-          </a:p>
-        </p:txBody>
-      </p:sp>
-      <p:sp>
-        <p:nvSpPr>
-          <p:cNvPr id="20" name="Text 17"/>
+              <a:rPr lang="en-US" sz="1400" i="1" dirty="0">
+                <a:solidFill>
+                  <a:srgbClr val="6B5F59"/>
+                </a:solidFill>
+              </a:rPr>
+              <a:t>Figura 23.4 — Acessibilidade, trabalho e formação, com a IA como ferramenta.</a:t>
+            </a:r>
+            <a:endParaRPr lang="en-US" sz="1400" dirty="0"/>
+          </a:p>
+        </p:txBody>
+      </p:sp>
+      <p:sp>
+        <p:nvSpPr>
+          <p:cNvPr id="6" name="Text 2"/>
           <p:cNvSpPr txBox="1"/>
           <p:nvPr/>
         </p:nvSpPr>
@@ -11020,6 +10617,734 @@
 <file path=ppt/slides/slide22.xml><?xml version="1.0" encoding="utf-8"?>
 <p:sld xmlns:a="http://schemas.openxmlformats.org/drawingml/2006/main" xmlns:r="http://schemas.openxmlformats.org/officeDocument/2006/relationships" xmlns:p="http://schemas.openxmlformats.org/presentationml/2006/main">
   <p:cSld name="Slide 22">
+    <p:bg>
+      <p:bgPr>
+        <a:solidFill>
+          <a:srgbClr val="6D3B6E"/>
+        </a:solidFill>
+      </p:bgPr>
+    </p:bg>
+    <p:spTree>
+      <p:nvGrpSpPr>
+        <p:cNvPr id="1" name=""/>
+        <p:cNvGrpSpPr/>
+        <p:nvPr/>
+      </p:nvGrpSpPr>
+      <p:grpSpPr>
+        <a:xfrm>
+          <a:off x="0" y="0"/>
+          <a:ext cx="0" cy="0"/>
+          <a:chOff x="0" y="0"/>
+          <a:chExt cx="0" cy="0"/>
+        </a:xfrm>
+      </p:grpSpPr>
+      <p:sp>
+        <p:nvSpPr>
+          <p:cNvPr id="3" name="Text 0"/>
+          <p:cNvSpPr txBox="1"/>
+          <p:nvPr/>
+        </p:nvSpPr>
+        <p:spPr>
+          <a:xfrm>
+            <a:off x="548640" y="365760"/>
+            <a:ext cx="11064240" cy="822960"/>
+          </a:xfrm>
+          <a:prstGeom prst="rect">
+            <a:avLst/>
+          </a:prstGeom>
+          <a:noFill/>
+          <a:ln/>
+        </p:spPr>
+        <p:txBody>
+          <a:bodyPr wrap="square" lIns="0" tIns="0" rIns="0" bIns="0" rtlCol="0" anchor="t"/>
+          <a:lstStyle/>
+          <a:p>
+            <a:pPr indent="0" marL="0">
+              <a:buNone/>
+            </a:pPr>
+            <a:r>
+              <a:rPr lang="en-US" sz="3400" b="1" dirty="0">
+                <a:solidFill>
+                  <a:srgbClr val="FFFFFF"/>
+                </a:solidFill>
+                <a:latin typeface="Cambria" pitchFamily="34" charset="0"/>
+                <a:ea typeface="Cambria" pitchFamily="34" charset="-122"/>
+                <a:cs typeface="Cambria" pitchFamily="34" charset="-120"/>
+              </a:rPr>
+              <a:t>O que vale a pena lembrar</a:t>
+            </a:r>
+            <a:endParaRPr lang="en-US" sz="3400" dirty="0"/>
+          </a:p>
+        </p:txBody>
+      </p:sp>
+      <p:sp>
+        <p:nvSpPr>
+          <p:cNvPr id="4" name="Shape 1"/>
+          <p:cNvSpPr/>
+          <p:nvPr/>
+        </p:nvSpPr>
+        <p:spPr>
+          <a:xfrm>
+            <a:off x="548640" y="1417320"/>
+            <a:ext cx="11064240" cy="762000"/>
+          </a:xfrm>
+          <a:prstGeom prst="roundRect">
+            <a:avLst>
+              <a:gd name="adj" fmla="val 14400"/>
+            </a:avLst>
+          </a:prstGeom>
+          <a:solidFill>
+            <a:srgbClr val="FFFFFF">
+              <a:alpha val="88000"/>
+            </a:srgbClr>
+          </a:solidFill>
+          <a:ln w="12700">
+            <a:solidFill>
+              <a:srgbClr val="FFFFFF">
+                <a:alpha val="88000"/>
+              </a:srgbClr>
+            </a:solidFill>
+            <a:prstDash val="solid"/>
+          </a:ln>
+        </p:spPr>
+      </p:sp>
+      <p:sp>
+        <p:nvSpPr>
+          <p:cNvPr id="5" name="Text 2"/>
+          <p:cNvSpPr txBox="1"/>
+          <p:nvPr/>
+        </p:nvSpPr>
+        <p:spPr>
+          <a:xfrm>
+            <a:off x="731520" y="1417320"/>
+            <a:ext cx="548640" cy="762000"/>
+          </a:xfrm>
+          <a:prstGeom prst="rect">
+            <a:avLst/>
+          </a:prstGeom>
+          <a:noFill/>
+          <a:ln/>
+        </p:spPr>
+        <p:txBody>
+          <a:bodyPr wrap="square" lIns="0" tIns="0" rIns="0" bIns="0" rtlCol="0" anchor="ctr"/>
+          <a:lstStyle/>
+          <a:p>
+            <a:pPr algn="ctr" indent="0" marL="0">
+              <a:buNone/>
+            </a:pPr>
+            <a:r>
+              <a:rPr lang="en-US" sz="2400" b="1" dirty="0">
+                <a:solidFill>
+                  <a:srgbClr val="6D3B6E"/>
+                </a:solidFill>
+              </a:rPr>
+              <a:t>✓</a:t>
+            </a:r>
+            <a:endParaRPr lang="en-US" sz="2400" dirty="0"/>
+          </a:p>
+        </p:txBody>
+      </p:sp>
+      <p:sp>
+        <p:nvSpPr>
+          <p:cNvPr id="6" name="Text 3"/>
+          <p:cNvSpPr txBox="1"/>
+          <p:nvPr/>
+        </p:nvSpPr>
+        <p:spPr>
+          <a:xfrm>
+            <a:off x="1463040" y="1417320"/>
+            <a:ext cx="9966960" cy="762000"/>
+          </a:xfrm>
+          <a:prstGeom prst="rect">
+            <a:avLst/>
+          </a:prstGeom>
+          <a:noFill/>
+          <a:ln/>
+        </p:spPr>
+        <p:txBody>
+          <a:bodyPr wrap="square" lIns="0" tIns="0" rIns="0" bIns="0" rtlCol="0" anchor="ctr"/>
+          <a:lstStyle/>
+          <a:p>
+            <a:pPr indent="0" marL="0">
+              <a:buNone/>
+            </a:pPr>
+            <a:r>
+              <a:rPr lang="en-US" sz="1800" b="1" dirty="0">
+                <a:solidFill>
+                  <a:srgbClr val="3B2A2A"/>
+                </a:solidFill>
+              </a:rPr>
+              <a:t>Acessibilidade é direito e prática: barreiras estão no material</a:t>
+            </a:r>
+            <a:endParaRPr lang="en-US" sz="1800" dirty="0"/>
+          </a:p>
+        </p:txBody>
+      </p:sp>
+      <p:sp>
+        <p:nvSpPr>
+          <p:cNvPr id="7" name="Shape 4"/>
+          <p:cNvSpPr/>
+          <p:nvPr/>
+        </p:nvSpPr>
+        <p:spPr>
+          <a:xfrm>
+            <a:off x="548640" y="2289048"/>
+            <a:ext cx="11064240" cy="762000"/>
+          </a:xfrm>
+          <a:prstGeom prst="roundRect">
+            <a:avLst>
+              <a:gd name="adj" fmla="val 14400"/>
+            </a:avLst>
+          </a:prstGeom>
+          <a:solidFill>
+            <a:srgbClr val="FFFFFF">
+              <a:alpha val="88000"/>
+            </a:srgbClr>
+          </a:solidFill>
+          <a:ln w="12700">
+            <a:solidFill>
+              <a:srgbClr val="FFFFFF">
+                <a:alpha val="88000"/>
+              </a:srgbClr>
+            </a:solidFill>
+            <a:prstDash val="solid"/>
+          </a:ln>
+        </p:spPr>
+      </p:sp>
+      <p:sp>
+        <p:nvSpPr>
+          <p:cNvPr id="8" name="Text 5"/>
+          <p:cNvSpPr txBox="1"/>
+          <p:nvPr/>
+        </p:nvSpPr>
+        <p:spPr>
+          <a:xfrm>
+            <a:off x="731520" y="2289048"/>
+            <a:ext cx="548640" cy="762000"/>
+          </a:xfrm>
+          <a:prstGeom prst="rect">
+            <a:avLst/>
+          </a:prstGeom>
+          <a:noFill/>
+          <a:ln/>
+        </p:spPr>
+        <p:txBody>
+          <a:bodyPr wrap="square" lIns="0" tIns="0" rIns="0" bIns="0" rtlCol="0" anchor="ctr"/>
+          <a:lstStyle/>
+          <a:p>
+            <a:pPr algn="ctr" indent="0" marL="0">
+              <a:buNone/>
+            </a:pPr>
+            <a:r>
+              <a:rPr lang="en-US" sz="2400" b="1" dirty="0">
+                <a:solidFill>
+                  <a:srgbClr val="6D3B6E"/>
+                </a:solidFill>
+              </a:rPr>
+              <a:t>✓</a:t>
+            </a:r>
+            <a:endParaRPr lang="en-US" sz="2400" dirty="0"/>
+          </a:p>
+        </p:txBody>
+      </p:sp>
+      <p:sp>
+        <p:nvSpPr>
+          <p:cNvPr id="9" name="Text 6"/>
+          <p:cNvSpPr txBox="1"/>
+          <p:nvPr/>
+        </p:nvSpPr>
+        <p:spPr>
+          <a:xfrm>
+            <a:off x="1463040" y="2289048"/>
+            <a:ext cx="9966960" cy="762000"/>
+          </a:xfrm>
+          <a:prstGeom prst="rect">
+            <a:avLst/>
+          </a:prstGeom>
+          <a:noFill/>
+          <a:ln/>
+        </p:spPr>
+        <p:txBody>
+          <a:bodyPr wrap="square" lIns="0" tIns="0" rIns="0" bIns="0" rtlCol="0" anchor="ctr"/>
+          <a:lstStyle/>
+          <a:p>
+            <a:pPr indent="0" marL="0">
+              <a:buNone/>
+            </a:pPr>
+            <a:r>
+              <a:rPr lang="en-US" sz="1800" b="1" dirty="0">
+                <a:solidFill>
+                  <a:srgbClr val="3B2A2A"/>
+                </a:solidFill>
+              </a:rPr>
+              <a:t>Desenho universal planeja para muitos ao mesmo tempo</a:t>
+            </a:r>
+            <a:endParaRPr lang="en-US" sz="1800" dirty="0"/>
+          </a:p>
+        </p:txBody>
+      </p:sp>
+      <p:sp>
+        <p:nvSpPr>
+          <p:cNvPr id="10" name="Shape 7"/>
+          <p:cNvSpPr/>
+          <p:nvPr/>
+        </p:nvSpPr>
+        <p:spPr>
+          <a:xfrm>
+            <a:off x="548640" y="3160776"/>
+            <a:ext cx="11064240" cy="762000"/>
+          </a:xfrm>
+          <a:prstGeom prst="roundRect">
+            <a:avLst>
+              <a:gd name="adj" fmla="val 14400"/>
+            </a:avLst>
+          </a:prstGeom>
+          <a:solidFill>
+            <a:srgbClr val="FFFFFF">
+              <a:alpha val="88000"/>
+            </a:srgbClr>
+          </a:solidFill>
+          <a:ln w="12700">
+            <a:solidFill>
+              <a:srgbClr val="FFFFFF">
+                <a:alpha val="88000"/>
+              </a:srgbClr>
+            </a:solidFill>
+            <a:prstDash val="solid"/>
+          </a:ln>
+        </p:spPr>
+      </p:sp>
+      <p:sp>
+        <p:nvSpPr>
+          <p:cNvPr id="11" name="Text 8"/>
+          <p:cNvSpPr txBox="1"/>
+          <p:nvPr/>
+        </p:nvSpPr>
+        <p:spPr>
+          <a:xfrm>
+            <a:off x="731520" y="3160776"/>
+            <a:ext cx="548640" cy="762000"/>
+          </a:xfrm>
+          <a:prstGeom prst="rect">
+            <a:avLst/>
+          </a:prstGeom>
+          <a:noFill/>
+          <a:ln/>
+        </p:spPr>
+        <p:txBody>
+          <a:bodyPr wrap="square" lIns="0" tIns="0" rIns="0" bIns="0" rtlCol="0" anchor="ctr"/>
+          <a:lstStyle/>
+          <a:p>
+            <a:pPr algn="ctr" indent="0" marL="0">
+              <a:buNone/>
+            </a:pPr>
+            <a:r>
+              <a:rPr lang="en-US" sz="2400" b="1" dirty="0">
+                <a:solidFill>
+                  <a:srgbClr val="6D3B6E"/>
+                </a:solidFill>
+              </a:rPr>
+              <a:t>✓</a:t>
+            </a:r>
+            <a:endParaRPr lang="en-US" sz="2400" dirty="0"/>
+          </a:p>
+        </p:txBody>
+      </p:sp>
+      <p:sp>
+        <p:nvSpPr>
+          <p:cNvPr id="12" name="Text 9"/>
+          <p:cNvSpPr txBox="1"/>
+          <p:nvPr/>
+        </p:nvSpPr>
+        <p:spPr>
+          <a:xfrm>
+            <a:off x="1463040" y="3160776"/>
+            <a:ext cx="9966960" cy="762000"/>
+          </a:xfrm>
+          <a:prstGeom prst="rect">
+            <a:avLst/>
+          </a:prstGeom>
+          <a:noFill/>
+          <a:ln/>
+        </p:spPr>
+        <p:txBody>
+          <a:bodyPr wrap="square" lIns="0" tIns="0" rIns="0" bIns="0" rtlCol="0" anchor="ctr"/>
+          <a:lstStyle/>
+          <a:p>
+            <a:pPr indent="0" marL="0">
+              <a:buNone/>
+            </a:pPr>
+            <a:r>
+              <a:rPr lang="en-US" sz="1800" b="1" dirty="0">
+                <a:solidFill>
+                  <a:srgbClr val="3B2A2A"/>
+                </a:solidFill>
+              </a:rPr>
+              <a:t>A IA rascunha; você verifica com o original e testa com o estudante</a:t>
+            </a:r>
+            <a:endParaRPr lang="en-US" sz="1800" dirty="0"/>
+          </a:p>
+        </p:txBody>
+      </p:sp>
+      <p:sp>
+        <p:nvSpPr>
+          <p:cNvPr id="13" name="Shape 10"/>
+          <p:cNvSpPr/>
+          <p:nvPr/>
+        </p:nvSpPr>
+        <p:spPr>
+          <a:xfrm>
+            <a:off x="548640" y="4032504"/>
+            <a:ext cx="11064240" cy="762000"/>
+          </a:xfrm>
+          <a:prstGeom prst="roundRect">
+            <a:avLst>
+              <a:gd name="adj" fmla="val 14400"/>
+            </a:avLst>
+          </a:prstGeom>
+          <a:solidFill>
+            <a:srgbClr val="FFFFFF">
+              <a:alpha val="88000"/>
+            </a:srgbClr>
+          </a:solidFill>
+          <a:ln w="12700">
+            <a:solidFill>
+              <a:srgbClr val="FFFFFF">
+                <a:alpha val="88000"/>
+              </a:srgbClr>
+            </a:solidFill>
+            <a:prstDash val="solid"/>
+          </a:ln>
+        </p:spPr>
+      </p:sp>
+      <p:sp>
+        <p:nvSpPr>
+          <p:cNvPr id="14" name="Text 11"/>
+          <p:cNvSpPr txBox="1"/>
+          <p:nvPr/>
+        </p:nvSpPr>
+        <p:spPr>
+          <a:xfrm>
+            <a:off x="731520" y="4032504"/>
+            <a:ext cx="548640" cy="762000"/>
+          </a:xfrm>
+          <a:prstGeom prst="rect">
+            <a:avLst/>
+          </a:prstGeom>
+          <a:noFill/>
+          <a:ln/>
+        </p:spPr>
+        <p:txBody>
+          <a:bodyPr wrap="square" lIns="0" tIns="0" rIns="0" bIns="0" rtlCol="0" anchor="ctr"/>
+          <a:lstStyle/>
+          <a:p>
+            <a:pPr algn="ctr" indent="0" marL="0">
+              <a:buNone/>
+            </a:pPr>
+            <a:r>
+              <a:rPr lang="en-US" sz="2400" b="1" dirty="0">
+                <a:solidFill>
+                  <a:srgbClr val="6D3B6E"/>
+                </a:solidFill>
+              </a:rPr>
+              <a:t>✓</a:t>
+            </a:r>
+            <a:endParaRPr lang="en-US" sz="2400" dirty="0"/>
+          </a:p>
+        </p:txBody>
+      </p:sp>
+      <p:sp>
+        <p:nvSpPr>
+          <p:cNvPr id="15" name="Text 12"/>
+          <p:cNvSpPr txBox="1"/>
+          <p:nvPr/>
+        </p:nvSpPr>
+        <p:spPr>
+          <a:xfrm>
+            <a:off x="1463040" y="4032504"/>
+            <a:ext cx="9966960" cy="762000"/>
+          </a:xfrm>
+          <a:prstGeom prst="rect">
+            <a:avLst/>
+          </a:prstGeom>
+          <a:noFill/>
+          <a:ln/>
+        </p:spPr>
+        <p:txBody>
+          <a:bodyPr wrap="square" lIns="0" tIns="0" rIns="0" bIns="0" rtlCol="0" anchor="ctr"/>
+          <a:lstStyle/>
+          <a:p>
+            <a:pPr indent="0" marL="0">
+              <a:buNone/>
+            </a:pPr>
+            <a:r>
+              <a:rPr lang="en-US" sz="1800" b="1" dirty="0">
+                <a:solidFill>
+                  <a:srgbClr val="3B2A2A"/>
+                </a:solidFill>
+              </a:rPr>
+              <a:t>Dados de saúde e deficiência são sensíveis: não os insira</a:t>
+            </a:r>
+            <a:endParaRPr lang="en-US" sz="1800" dirty="0"/>
+          </a:p>
+        </p:txBody>
+      </p:sp>
+      <p:sp>
+        <p:nvSpPr>
+          <p:cNvPr id="16" name="Shape 13"/>
+          <p:cNvSpPr/>
+          <p:nvPr/>
+        </p:nvSpPr>
+        <p:spPr>
+          <a:xfrm>
+            <a:off x="548640" y="4904232"/>
+            <a:ext cx="11064240" cy="762000"/>
+          </a:xfrm>
+          <a:prstGeom prst="roundRect">
+            <a:avLst>
+              <a:gd name="adj" fmla="val 14400"/>
+            </a:avLst>
+          </a:prstGeom>
+          <a:solidFill>
+            <a:srgbClr val="FFFFFF">
+              <a:alpha val="88000"/>
+            </a:srgbClr>
+          </a:solidFill>
+          <a:ln w="12700">
+            <a:solidFill>
+              <a:srgbClr val="FFFFFF">
+                <a:alpha val="88000"/>
+              </a:srgbClr>
+            </a:solidFill>
+            <a:prstDash val="solid"/>
+          </a:ln>
+        </p:spPr>
+      </p:sp>
+      <p:sp>
+        <p:nvSpPr>
+          <p:cNvPr id="17" name="Text 14"/>
+          <p:cNvSpPr txBox="1"/>
+          <p:nvPr/>
+        </p:nvSpPr>
+        <p:spPr>
+          <a:xfrm>
+            <a:off x="731520" y="4904232"/>
+            <a:ext cx="548640" cy="762000"/>
+          </a:xfrm>
+          <a:prstGeom prst="rect">
+            <a:avLst/>
+          </a:prstGeom>
+          <a:noFill/>
+          <a:ln/>
+        </p:spPr>
+        <p:txBody>
+          <a:bodyPr wrap="square" lIns="0" tIns="0" rIns="0" bIns="0" rtlCol="0" anchor="ctr"/>
+          <a:lstStyle/>
+          <a:p>
+            <a:pPr algn="ctr" indent="0" marL="0">
+              <a:buNone/>
+            </a:pPr>
+            <a:r>
+              <a:rPr lang="en-US" sz="2400" b="1" dirty="0">
+                <a:solidFill>
+                  <a:srgbClr val="6D3B6E"/>
+                </a:solidFill>
+              </a:rPr>
+              <a:t>✓</a:t>
+            </a:r>
+            <a:endParaRPr lang="en-US" sz="2400" dirty="0"/>
+          </a:p>
+        </p:txBody>
+      </p:sp>
+      <p:sp>
+        <p:nvSpPr>
+          <p:cNvPr id="18" name="Text 15"/>
+          <p:cNvSpPr txBox="1"/>
+          <p:nvPr/>
+        </p:nvSpPr>
+        <p:spPr>
+          <a:xfrm>
+            <a:off x="1463040" y="4904232"/>
+            <a:ext cx="9966960" cy="762000"/>
+          </a:xfrm>
+          <a:prstGeom prst="rect">
+            <a:avLst/>
+          </a:prstGeom>
+          <a:noFill/>
+          <a:ln/>
+        </p:spPr>
+        <p:txBody>
+          <a:bodyPr wrap="square" lIns="0" tIns="0" rIns="0" bIns="0" rtlCol="0" anchor="ctr"/>
+          <a:lstStyle/>
+          <a:p>
+            <a:pPr indent="0" marL="0">
+              <a:buNone/>
+            </a:pPr>
+            <a:r>
+              <a:rPr lang="en-US" sz="1800" b="1" dirty="0">
+                <a:solidFill>
+                  <a:srgbClr val="3B2A2A"/>
+                </a:solidFill>
+              </a:rPr>
+              <a:t>Conte a revisão no tempo; use triagem, banco e limites</a:t>
+            </a:r>
+            <a:endParaRPr lang="en-US" sz="1800" dirty="0"/>
+          </a:p>
+        </p:txBody>
+      </p:sp>
+      <p:sp>
+        <p:nvSpPr>
+          <p:cNvPr id="19" name="Shape 16"/>
+          <p:cNvSpPr/>
+          <p:nvPr/>
+        </p:nvSpPr>
+        <p:spPr>
+          <a:xfrm>
+            <a:off x="548640" y="5775960"/>
+            <a:ext cx="11064240" cy="762000"/>
+          </a:xfrm>
+          <a:prstGeom prst="roundRect">
+            <a:avLst>
+              <a:gd name="adj" fmla="val 14400"/>
+            </a:avLst>
+          </a:prstGeom>
+          <a:solidFill>
+            <a:srgbClr val="FFFFFF">
+              <a:alpha val="88000"/>
+            </a:srgbClr>
+          </a:solidFill>
+          <a:ln w="12700">
+            <a:solidFill>
+              <a:srgbClr val="FFFFFF">
+                <a:alpha val="88000"/>
+              </a:srgbClr>
+            </a:solidFill>
+            <a:prstDash val="solid"/>
+          </a:ln>
+        </p:spPr>
+      </p:sp>
+      <p:sp>
+        <p:nvSpPr>
+          <p:cNvPr id="20" name="Text 17"/>
+          <p:cNvSpPr txBox="1"/>
+          <p:nvPr/>
+        </p:nvSpPr>
+        <p:spPr>
+          <a:xfrm>
+            <a:off x="731520" y="5775960"/>
+            <a:ext cx="548640" cy="762000"/>
+          </a:xfrm>
+          <a:prstGeom prst="rect">
+            <a:avLst/>
+          </a:prstGeom>
+          <a:noFill/>
+          <a:ln/>
+        </p:spPr>
+        <p:txBody>
+          <a:bodyPr wrap="square" lIns="0" tIns="0" rIns="0" bIns="0" rtlCol="0" anchor="ctr"/>
+          <a:lstStyle/>
+          <a:p>
+            <a:pPr algn="ctr" indent="0" marL="0">
+              <a:buNone/>
+            </a:pPr>
+            <a:r>
+              <a:rPr lang="en-US" sz="2400" b="1" dirty="0">
+                <a:solidFill>
+                  <a:srgbClr val="6D3B6E"/>
+                </a:solidFill>
+              </a:rPr>
+              <a:t>✓</a:t>
+            </a:r>
+            <a:endParaRPr lang="en-US" sz="2400" dirty="0"/>
+          </a:p>
+        </p:txBody>
+      </p:sp>
+      <p:sp>
+        <p:nvSpPr>
+          <p:cNvPr id="21" name="Text 18"/>
+          <p:cNvSpPr txBox="1"/>
+          <p:nvPr/>
+        </p:nvSpPr>
+        <p:spPr>
+          <a:xfrm>
+            <a:off x="1463040" y="5775960"/>
+            <a:ext cx="9966960" cy="762000"/>
+          </a:xfrm>
+          <a:prstGeom prst="rect">
+            <a:avLst/>
+          </a:prstGeom>
+          <a:noFill/>
+          <a:ln/>
+        </p:spPr>
+        <p:txBody>
+          <a:bodyPr wrap="square" lIns="0" tIns="0" rIns="0" bIns="0" rtlCol="0" anchor="ctr"/>
+          <a:lstStyle/>
+          <a:p>
+            <a:pPr indent="0" marL="0">
+              <a:buNone/>
+            </a:pPr>
+            <a:r>
+              <a:rPr lang="en-US" sz="1800" b="1" dirty="0">
+                <a:solidFill>
+                  <a:srgbClr val="3B2A2A"/>
+                </a:solidFill>
+              </a:rPr>
+              <a:t>Formação efetiva é ativa, colaborativa e contínua</a:t>
+            </a:r>
+            <a:endParaRPr lang="en-US" sz="1800" dirty="0"/>
+          </a:p>
+        </p:txBody>
+      </p:sp>
+      <p:sp>
+        <p:nvSpPr>
+          <p:cNvPr id="22" name="Text 19"/>
+          <p:cNvSpPr txBox="1"/>
+          <p:nvPr/>
+        </p:nvSpPr>
+        <p:spPr>
+          <a:xfrm>
+            <a:off x="548640" y="6446520"/>
+            <a:ext cx="5486400" cy="274320"/>
+          </a:xfrm>
+          <a:prstGeom prst="rect">
+            <a:avLst/>
+          </a:prstGeom>
+          <a:noFill/>
+          <a:ln/>
+        </p:spPr>
+        <p:txBody>
+          <a:bodyPr wrap="square" lIns="0" tIns="0" rIns="0" bIns="0" rtlCol="0" anchor="ctr"/>
+          <a:lstStyle/>
+          <a:p>
+            <a:pPr indent="0" marL="0">
+              <a:buNone/>
+            </a:pPr>
+            <a:r>
+              <a:rPr lang="en-US" sz="1000" dirty="0">
+                <a:solidFill>
+                  <a:srgbClr val="E9D9C8"/>
+                </a:solidFill>
+                <a:latin typeface="Calibri" pitchFamily="34" charset="0"/>
+                <a:ea typeface="Calibri" pitchFamily="34" charset="-122"/>
+                <a:cs typeface="Calibri" pitchFamily="34" charset="-120"/>
+              </a:rPr>
+              <a:t>IA aplicada à Educação · Cap. 23</a:t>
+            </a:r>
+            <a:endParaRPr lang="en-US" sz="1000" dirty="0"/>
+          </a:p>
+        </p:txBody>
+      </p:sp>
+    </p:spTree>
+  </p:cSld>
+  <p:clrMapOvr>
+    <a:masterClrMapping/>
+  </p:clrMapOvr>
+</p:sld>
+</file>
+
+<file path=ppt/slides/slide23.xml><?xml version="1.0" encoding="utf-8"?>
+<p:sld xmlns:a="http://schemas.openxmlformats.org/drawingml/2006/main" xmlns:r="http://schemas.openxmlformats.org/officeDocument/2006/relationships" xmlns:p="http://schemas.openxmlformats.org/presentationml/2006/main">
+  <p:cSld name="Slide 23">
     <p:bg>
       <p:bgPr>
         <a:solidFill>
@@ -11074,46 +11399,74 @@
                 <a:ea typeface="Cambria" pitchFamily="34" charset="-122"/>
                 <a:cs typeface="Cambria" pitchFamily="34" charset="-120"/>
               </a:rPr>
-              <a:t>Síntese: apoio entre estudantes, professores e colegas</a:t>
+              <a:t>Para pensar na sua prática</a:t>
             </a:r>
             <a:endParaRPr lang="en-US" sz="3400" dirty="0"/>
           </a:p>
         </p:txBody>
       </p:sp>
-      <p:pic>
-        <p:nvPicPr>
-          <p:cNvPr id="4" name="Image 0" descr="Figura 23.4 — Acessibilidade, trabalho e formação, com a IA como ferramenta.">    </p:cNvPr>
-          <p:cNvPicPr>
-            <a:picLocks noChangeAspect="1"/>
-          </p:cNvPicPr>
-          <p:nvPr/>
-        </p:nvPicPr>
-        <p:blipFill>
-          <a:blip r:embed="rId1"/>
-          <a:stretch>
-            <a:fillRect/>
-          </a:stretch>
-        </p:blipFill>
-        <p:spPr>
-          <a:xfrm>
-            <a:off x="1856957" y="1325880"/>
-            <a:ext cx="8447606" cy="4434840"/>
-          </a:xfrm>
-          <a:prstGeom prst="rect">
-            <a:avLst/>
-          </a:prstGeom>
-        </p:spPr>
-      </p:pic>
-      <p:sp>
-        <p:nvSpPr>
-          <p:cNvPr id="5" name="Text 1"/>
-          <p:cNvSpPr txBox="1"/>
-          <p:nvPr/>
-        </p:nvSpPr>
-        <p:spPr>
-          <a:xfrm>
-            <a:off x="548640" y="5852160"/>
-            <a:ext cx="11064240" cy="548640"/>
+      <p:sp>
+        <p:nvSpPr>
+          <p:cNvPr id="4" name="Shape 1"/>
+          <p:cNvSpPr/>
+          <p:nvPr/>
+        </p:nvSpPr>
+        <p:spPr>
+          <a:xfrm>
+            <a:off x="548640" y="1463040"/>
+            <a:ext cx="11064240" cy="1097280"/>
+          </a:xfrm>
+          <a:prstGeom prst="roundRect">
+            <a:avLst>
+              <a:gd name="adj" fmla="val 10000"/>
+            </a:avLst>
+          </a:prstGeom>
+          <a:solidFill>
+            <a:srgbClr val="F7EFE6"/>
+          </a:solidFill>
+          <a:ln w="12700">
+            <a:solidFill>
+              <a:srgbClr val="F7EFE6"/>
+            </a:solidFill>
+            <a:prstDash val="solid"/>
+          </a:ln>
+        </p:spPr>
+      </p:sp>
+      <p:sp>
+        <p:nvSpPr>
+          <p:cNvPr id="5" name="Shape 2"/>
+          <p:cNvSpPr/>
+          <p:nvPr/>
+        </p:nvSpPr>
+        <p:spPr>
+          <a:xfrm>
+            <a:off x="777240" y="1737360"/>
+            <a:ext cx="548640" cy="548640"/>
+          </a:xfrm>
+          <a:prstGeom prst="ellipse">
+            <a:avLst/>
+          </a:prstGeom>
+          <a:solidFill>
+            <a:srgbClr val="6D3B6E"/>
+          </a:solidFill>
+          <a:ln w="12700">
+            <a:solidFill>
+              <a:srgbClr val="6D3B6E"/>
+            </a:solidFill>
+            <a:prstDash val="solid"/>
+          </a:ln>
+        </p:spPr>
+      </p:sp>
+      <p:sp>
+        <p:nvSpPr>
+          <p:cNvPr id="6" name="Text 3"/>
+          <p:cNvSpPr txBox="1"/>
+          <p:nvPr/>
+        </p:nvSpPr>
+        <p:spPr>
+          <a:xfrm>
+            <a:off x="777240" y="1737360"/>
+            <a:ext cx="548640" cy="548640"/>
           </a:xfrm>
           <a:prstGeom prst="rect">
             <a:avLst/>
@@ -11129,114 +11482,7 @@
               <a:buNone/>
             </a:pPr>
             <a:r>
-              <a:rPr lang="en-US" sz="1400" i="1" dirty="0">
-                <a:solidFill>
-                  <a:srgbClr val="6B5F59"/>
-                </a:solidFill>
-              </a:rPr>
-              <a:t>Figura 23.4 — Acessibilidade, trabalho e formação, com a IA como ferramenta.</a:t>
-            </a:r>
-            <a:endParaRPr lang="en-US" sz="1400" dirty="0"/>
-          </a:p>
-        </p:txBody>
-      </p:sp>
-      <p:sp>
-        <p:nvSpPr>
-          <p:cNvPr id="6" name="Text 2"/>
-          <p:cNvSpPr txBox="1"/>
-          <p:nvPr/>
-        </p:nvSpPr>
-        <p:spPr>
-          <a:xfrm>
-            <a:off x="548640" y="6446520"/>
-            <a:ext cx="5486400" cy="274320"/>
-          </a:xfrm>
-          <a:prstGeom prst="rect">
-            <a:avLst/>
-          </a:prstGeom>
-          <a:noFill/>
-          <a:ln/>
-        </p:spPr>
-        <p:txBody>
-          <a:bodyPr wrap="square" lIns="0" tIns="0" rIns="0" bIns="0" rtlCol="0" anchor="ctr"/>
-          <a:lstStyle/>
-          <a:p>
-            <a:pPr indent="0" marL="0">
-              <a:buNone/>
-            </a:pPr>
-            <a:r>
-              <a:rPr lang="en-US" sz="1000" dirty="0">
-                <a:solidFill>
-                  <a:srgbClr val="6B5F59"/>
-                </a:solidFill>
-                <a:latin typeface="Calibri" pitchFamily="34" charset="0"/>
-                <a:ea typeface="Calibri" pitchFamily="34" charset="-122"/>
-                <a:cs typeface="Calibri" pitchFamily="34" charset="-120"/>
-              </a:rPr>
-              <a:t>IA aplicada à Educação · Cap. 23</a:t>
-            </a:r>
-            <a:endParaRPr lang="en-US" sz="1000" dirty="0"/>
-          </a:p>
-        </p:txBody>
-      </p:sp>
-    </p:spTree>
-  </p:cSld>
-  <p:clrMapOvr>
-    <a:masterClrMapping/>
-  </p:clrMapOvr>
-</p:sld>
-</file>
-
-<file path=ppt/slides/slide23.xml><?xml version="1.0" encoding="utf-8"?>
-<p:sld xmlns:a="http://schemas.openxmlformats.org/drawingml/2006/main" xmlns:r="http://schemas.openxmlformats.org/officeDocument/2006/relationships" xmlns:p="http://schemas.openxmlformats.org/presentationml/2006/main">
-  <p:cSld name="Slide 23">
-    <p:bg>
-      <p:bgPr>
-        <a:solidFill>
-          <a:srgbClr val="6D3B6E"/>
-        </a:solidFill>
-      </p:bgPr>
-    </p:bg>
-    <p:spTree>
-      <p:nvGrpSpPr>
-        <p:cNvPr id="1" name=""/>
-        <p:cNvGrpSpPr/>
-        <p:nvPr/>
-      </p:nvGrpSpPr>
-      <p:grpSpPr>
-        <a:xfrm>
-          <a:off x="0" y="0"/>
-          <a:ext cx="0" cy="0"/>
-          <a:chOff x="0" y="0"/>
-          <a:chExt cx="0" cy="0"/>
-        </a:xfrm>
-      </p:grpSpPr>
-      <p:sp>
-        <p:nvSpPr>
-          <p:cNvPr id="3" name="Text 0"/>
-          <p:cNvSpPr txBox="1"/>
-          <p:nvPr/>
-        </p:nvSpPr>
-        <p:spPr>
-          <a:xfrm>
-            <a:off x="548640" y="365760"/>
-            <a:ext cx="11064240" cy="822960"/>
-          </a:xfrm>
-          <a:prstGeom prst="rect">
-            <a:avLst/>
-          </a:prstGeom>
-          <a:noFill/>
-          <a:ln/>
-        </p:spPr>
-        <p:txBody>
-          <a:bodyPr wrap="square" lIns="0" tIns="0" rIns="0" bIns="0" rtlCol="0" anchor="t"/>
-          <a:lstStyle/>
-          <a:p>
-            <a:pPr indent="0" marL="0">
-              <a:buNone/>
-            </a:pPr>
-            <a:r>
-              <a:rPr lang="en-US" sz="3400" b="1" dirty="0">
+              <a:rPr lang="en-US" sz="1600" b="1" dirty="0">
                 <a:solidFill>
                   <a:srgbClr val="FFFFFF"/>
                 </a:solidFill>
@@ -11244,38 +11490,70 @@
                 <a:ea typeface="Cambria" pitchFamily="34" charset="-122"/>
                 <a:cs typeface="Cambria" pitchFamily="34" charset="-120"/>
               </a:rPr>
-              <a:t>O que vale a pena lembrar</a:t>
-            </a:r>
-            <a:endParaRPr lang="en-US" sz="3400" dirty="0"/>
-          </a:p>
-        </p:txBody>
-      </p:sp>
-      <p:sp>
-        <p:nvSpPr>
-          <p:cNvPr id="4" name="Shape 1"/>
+              <a:t>?</a:t>
+            </a:r>
+            <a:endParaRPr lang="en-US" sz="1600" dirty="0"/>
+          </a:p>
+        </p:txBody>
+      </p:sp>
+      <p:sp>
+        <p:nvSpPr>
+          <p:cNvPr id="7" name="Text 4"/>
+          <p:cNvSpPr txBox="1"/>
+          <p:nvPr/>
+        </p:nvSpPr>
+        <p:spPr>
+          <a:xfrm>
+            <a:off x="1600200" y="1463040"/>
+            <a:ext cx="9784080" cy="1097280"/>
+          </a:xfrm>
+          <a:prstGeom prst="rect">
+            <a:avLst/>
+          </a:prstGeom>
+          <a:noFill/>
+          <a:ln/>
+        </p:spPr>
+        <p:txBody>
+          <a:bodyPr wrap="square" lIns="0" tIns="0" rIns="0" bIns="0" rtlCol="0" anchor="ctr"/>
+          <a:lstStyle/>
+          <a:p>
+            <a:pPr indent="0" marL="0">
+              <a:buNone/>
+            </a:pPr>
+            <a:r>
+              <a:rPr lang="en-US" sz="2000" dirty="0">
+                <a:solidFill>
+                  <a:srgbClr val="3B2A2A"/>
+                </a:solidFill>
+              </a:rPr>
+              <a:t>Que barreira de acesso você reduziria esta semana, sem tecnologia?</a:t>
+            </a:r>
+            <a:endParaRPr lang="en-US" sz="2000" dirty="0"/>
+          </a:p>
+        </p:txBody>
+      </p:sp>
+      <p:sp>
+        <p:nvSpPr>
+          <p:cNvPr id="8" name="Shape 5"/>
           <p:cNvSpPr/>
           <p:nvPr/>
         </p:nvSpPr>
         <p:spPr>
           <a:xfrm>
-            <a:off x="548640" y="1417320"/>
-            <a:ext cx="11064240" cy="762000"/>
+            <a:off x="548640" y="2697480"/>
+            <a:ext cx="11064240" cy="1097280"/>
           </a:xfrm>
           <a:prstGeom prst="roundRect">
             <a:avLst>
-              <a:gd name="adj" fmla="val 14400"/>
+              <a:gd name="adj" fmla="val 10000"/>
             </a:avLst>
           </a:prstGeom>
           <a:solidFill>
-            <a:srgbClr val="FFFFFF">
-              <a:alpha val="88000"/>
-            </a:srgbClr>
+            <a:srgbClr val="F7EFE6"/>
           </a:solidFill>
           <a:ln w="12700">
             <a:solidFill>
-              <a:srgbClr val="FFFFFF">
-                <a:alpha val="88000"/>
-              </a:srgbClr>
+              <a:srgbClr val="F7EFE6"/>
             </a:solidFill>
             <a:prstDash val="solid"/>
           </a:ln>
@@ -11283,102 +11561,24 @@
       </p:sp>
       <p:sp>
         <p:nvSpPr>
-          <p:cNvPr id="5" name="Text 2"/>
-          <p:cNvSpPr txBox="1"/>
-          <p:nvPr/>
-        </p:nvSpPr>
-        <p:spPr>
-          <a:xfrm>
-            <a:off x="731520" y="1417320"/>
-            <a:ext cx="548640" cy="762000"/>
-          </a:xfrm>
-          <a:prstGeom prst="rect">
-            <a:avLst/>
-          </a:prstGeom>
-          <a:noFill/>
-          <a:ln/>
-        </p:spPr>
-        <p:txBody>
-          <a:bodyPr wrap="square" lIns="0" tIns="0" rIns="0" bIns="0" rtlCol="0" anchor="ctr"/>
-          <a:lstStyle/>
-          <a:p>
-            <a:pPr algn="ctr" indent="0" marL="0">
-              <a:buNone/>
-            </a:pPr>
-            <a:r>
-              <a:rPr lang="en-US" sz="2400" b="1" dirty="0">
-                <a:solidFill>
-                  <a:srgbClr val="6D3B6E"/>
-                </a:solidFill>
-              </a:rPr>
-              <a:t>✓</a:t>
-            </a:r>
-            <a:endParaRPr lang="en-US" sz="2400" dirty="0"/>
-          </a:p>
-        </p:txBody>
-      </p:sp>
-      <p:sp>
-        <p:nvSpPr>
-          <p:cNvPr id="6" name="Text 3"/>
-          <p:cNvSpPr txBox="1"/>
-          <p:nvPr/>
-        </p:nvSpPr>
-        <p:spPr>
-          <a:xfrm>
-            <a:off x="1463040" y="1417320"/>
-            <a:ext cx="9966960" cy="762000"/>
-          </a:xfrm>
-          <a:prstGeom prst="rect">
-            <a:avLst/>
-          </a:prstGeom>
-          <a:noFill/>
-          <a:ln/>
-        </p:spPr>
-        <p:txBody>
-          <a:bodyPr wrap="square" lIns="0" tIns="0" rIns="0" bIns="0" rtlCol="0" anchor="ctr"/>
-          <a:lstStyle/>
-          <a:p>
-            <a:pPr indent="0" marL="0">
-              <a:buNone/>
-            </a:pPr>
-            <a:r>
-              <a:rPr lang="en-US" sz="1800" b="1" dirty="0">
-                <a:solidFill>
-                  <a:srgbClr val="3B2A2A"/>
-                </a:solidFill>
-              </a:rPr>
-              <a:t>Acessibilidade é direito e prática: barreiras estão no material</a:t>
-            </a:r>
-            <a:endParaRPr lang="en-US" sz="1800" dirty="0"/>
-          </a:p>
-        </p:txBody>
-      </p:sp>
-      <p:sp>
-        <p:nvSpPr>
-          <p:cNvPr id="7" name="Shape 4"/>
+          <p:cNvPr id="9" name="Shape 6"/>
           <p:cNvSpPr/>
           <p:nvPr/>
         </p:nvSpPr>
         <p:spPr>
           <a:xfrm>
-            <a:off x="548640" y="2289048"/>
-            <a:ext cx="11064240" cy="762000"/>
-          </a:xfrm>
-          <a:prstGeom prst="roundRect">
-            <a:avLst>
-              <a:gd name="adj" fmla="val 14400"/>
-            </a:avLst>
+            <a:off x="777240" y="2971800"/>
+            <a:ext cx="548640" cy="548640"/>
+          </a:xfrm>
+          <a:prstGeom prst="ellipse">
+            <a:avLst/>
           </a:prstGeom>
           <a:solidFill>
-            <a:srgbClr val="FFFFFF">
-              <a:alpha val="88000"/>
-            </a:srgbClr>
+            <a:srgbClr val="6D3B6E"/>
           </a:solidFill>
           <a:ln w="12700">
             <a:solidFill>
-              <a:srgbClr val="FFFFFF">
-                <a:alpha val="88000"/>
-              </a:srgbClr>
+              <a:srgbClr val="6D3B6E"/>
             </a:solidFill>
             <a:prstDash val="solid"/>
           </a:ln>
@@ -11386,14 +11586,14 @@
       </p:sp>
       <p:sp>
         <p:nvSpPr>
-          <p:cNvPr id="8" name="Text 5"/>
-          <p:cNvSpPr txBox="1"/>
-          <p:nvPr/>
-        </p:nvSpPr>
-        <p:spPr>
-          <a:xfrm>
-            <a:off x="731520" y="2289048"/>
-            <a:ext cx="548640" cy="762000"/>
+          <p:cNvPr id="10" name="Text 7"/>
+          <p:cNvSpPr txBox="1"/>
+          <p:nvPr/>
+        </p:nvSpPr>
+        <p:spPr>
+          <a:xfrm>
+            <a:off x="777240" y="2971800"/>
+            <a:ext cx="548640" cy="548640"/>
           </a:xfrm>
           <a:prstGeom prst="rect">
             <a:avLst/>
@@ -11409,27 +11609,30 @@
               <a:buNone/>
             </a:pPr>
             <a:r>
-              <a:rPr lang="en-US" sz="2400" b="1" dirty="0">
-                <a:solidFill>
-                  <a:srgbClr val="6D3B6E"/>
-                </a:solidFill>
-              </a:rPr>
-              <a:t>✓</a:t>
-            </a:r>
-            <a:endParaRPr lang="en-US" sz="2400" dirty="0"/>
-          </a:p>
-        </p:txBody>
-      </p:sp>
-      <p:sp>
-        <p:nvSpPr>
-          <p:cNvPr id="9" name="Text 6"/>
-          <p:cNvSpPr txBox="1"/>
-          <p:nvPr/>
-        </p:nvSpPr>
-        <p:spPr>
-          <a:xfrm>
-            <a:off x="1463040" y="2289048"/>
-            <a:ext cx="9966960" cy="762000"/>
+              <a:rPr lang="en-US" sz="1600" b="1" dirty="0">
+                <a:solidFill>
+                  <a:srgbClr val="FFFFFF"/>
+                </a:solidFill>
+                <a:latin typeface="Cambria" pitchFamily="34" charset="0"/>
+                <a:ea typeface="Cambria" pitchFamily="34" charset="-122"/>
+                <a:cs typeface="Cambria" pitchFamily="34" charset="-120"/>
+              </a:rPr>
+              <a:t>?</a:t>
+            </a:r>
+            <a:endParaRPr lang="en-US" sz="1600" dirty="0"/>
+          </a:p>
+        </p:txBody>
+      </p:sp>
+      <p:sp>
+        <p:nvSpPr>
+          <p:cNvPr id="11" name="Text 8"/>
+          <p:cNvSpPr txBox="1"/>
+          <p:nvPr/>
+        </p:nvSpPr>
+        <p:spPr>
+          <a:xfrm>
+            <a:off x="1600200" y="2697480"/>
+            <a:ext cx="9784080" cy="1097280"/>
           </a:xfrm>
           <a:prstGeom prst="rect">
             <a:avLst/>
@@ -11445,43 +11648,39 @@
               <a:buNone/>
             </a:pPr>
             <a:r>
-              <a:rPr lang="en-US" sz="1800" b="1" dirty="0">
+              <a:rPr lang="en-US" sz="2000" dirty="0">
                 <a:solidFill>
                   <a:srgbClr val="3B2A2A"/>
                 </a:solidFill>
               </a:rPr>
-              <a:t>Desenho universal planeja para muitos ao mesmo tempo</a:t>
-            </a:r>
-            <a:endParaRPr lang="en-US" sz="1800" dirty="0"/>
-          </a:p>
-        </p:txBody>
-      </p:sp>
-      <p:sp>
-        <p:nvSpPr>
-          <p:cNvPr id="10" name="Shape 7"/>
+              <a:t>Como você verifica uma descrição de imagem produzida por IA?</a:t>
+            </a:r>
+            <a:endParaRPr lang="en-US" sz="2000" dirty="0"/>
+          </a:p>
+        </p:txBody>
+      </p:sp>
+      <p:sp>
+        <p:nvSpPr>
+          <p:cNvPr id="12" name="Shape 9"/>
           <p:cNvSpPr/>
           <p:nvPr/>
         </p:nvSpPr>
         <p:spPr>
           <a:xfrm>
-            <a:off x="548640" y="3160776"/>
-            <a:ext cx="11064240" cy="762000"/>
+            <a:off x="548640" y="3931920"/>
+            <a:ext cx="11064240" cy="1097280"/>
           </a:xfrm>
           <a:prstGeom prst="roundRect">
             <a:avLst>
-              <a:gd name="adj" fmla="val 14400"/>
+              <a:gd name="adj" fmla="val 10000"/>
             </a:avLst>
           </a:prstGeom>
           <a:solidFill>
-            <a:srgbClr val="FFFFFF">
-              <a:alpha val="88000"/>
-            </a:srgbClr>
+            <a:srgbClr val="F7EFE6"/>
           </a:solidFill>
           <a:ln w="12700">
             <a:solidFill>
-              <a:srgbClr val="FFFFFF">
-                <a:alpha val="88000"/>
-              </a:srgbClr>
+              <a:srgbClr val="F7EFE6"/>
             </a:solidFill>
             <a:prstDash val="solid"/>
           </a:ln>
@@ -11489,102 +11688,24 @@
       </p:sp>
       <p:sp>
         <p:nvSpPr>
-          <p:cNvPr id="11" name="Text 8"/>
-          <p:cNvSpPr txBox="1"/>
-          <p:nvPr/>
-        </p:nvSpPr>
-        <p:spPr>
-          <a:xfrm>
-            <a:off x="731520" y="3160776"/>
-            <a:ext cx="548640" cy="762000"/>
-          </a:xfrm>
-          <a:prstGeom prst="rect">
-            <a:avLst/>
-          </a:prstGeom>
-          <a:noFill/>
-          <a:ln/>
-        </p:spPr>
-        <p:txBody>
-          <a:bodyPr wrap="square" lIns="0" tIns="0" rIns="0" bIns="0" rtlCol="0" anchor="ctr"/>
-          <a:lstStyle/>
-          <a:p>
-            <a:pPr algn="ctr" indent="0" marL="0">
-              <a:buNone/>
-            </a:pPr>
-            <a:r>
-              <a:rPr lang="en-US" sz="2400" b="1" dirty="0">
-                <a:solidFill>
-                  <a:srgbClr val="6D3B6E"/>
-                </a:solidFill>
-              </a:rPr>
-              <a:t>✓</a:t>
-            </a:r>
-            <a:endParaRPr lang="en-US" sz="2400" dirty="0"/>
-          </a:p>
-        </p:txBody>
-      </p:sp>
-      <p:sp>
-        <p:nvSpPr>
-          <p:cNvPr id="12" name="Text 9"/>
-          <p:cNvSpPr txBox="1"/>
-          <p:nvPr/>
-        </p:nvSpPr>
-        <p:spPr>
-          <a:xfrm>
-            <a:off x="1463040" y="3160776"/>
-            <a:ext cx="9966960" cy="762000"/>
-          </a:xfrm>
-          <a:prstGeom prst="rect">
-            <a:avLst/>
-          </a:prstGeom>
-          <a:noFill/>
-          <a:ln/>
-        </p:spPr>
-        <p:txBody>
-          <a:bodyPr wrap="square" lIns="0" tIns="0" rIns="0" bIns="0" rtlCol="0" anchor="ctr"/>
-          <a:lstStyle/>
-          <a:p>
-            <a:pPr indent="0" marL="0">
-              <a:buNone/>
-            </a:pPr>
-            <a:r>
-              <a:rPr lang="en-US" sz="1800" b="1" dirty="0">
-                <a:solidFill>
-                  <a:srgbClr val="3B2A2A"/>
-                </a:solidFill>
-              </a:rPr>
-              <a:t>A IA rascunha; você verifica com o original e testa com o estudante</a:t>
-            </a:r>
-            <a:endParaRPr lang="en-US" sz="1800" dirty="0"/>
-          </a:p>
-        </p:txBody>
-      </p:sp>
-      <p:sp>
-        <p:nvSpPr>
           <p:cNvPr id="13" name="Shape 10"/>
           <p:cNvSpPr/>
           <p:nvPr/>
         </p:nvSpPr>
         <p:spPr>
           <a:xfrm>
-            <a:off x="548640" y="4032504"/>
-            <a:ext cx="11064240" cy="762000"/>
-          </a:xfrm>
-          <a:prstGeom prst="roundRect">
-            <a:avLst>
-              <a:gd name="adj" fmla="val 14400"/>
-            </a:avLst>
+            <a:off x="777240" y="4206240"/>
+            <a:ext cx="548640" cy="548640"/>
+          </a:xfrm>
+          <a:prstGeom prst="ellipse">
+            <a:avLst/>
           </a:prstGeom>
           <a:solidFill>
-            <a:srgbClr val="FFFFFF">
-              <a:alpha val="88000"/>
-            </a:srgbClr>
+            <a:srgbClr val="6D3B6E"/>
           </a:solidFill>
           <a:ln w="12700">
             <a:solidFill>
-              <a:srgbClr val="FFFFFF">
-                <a:alpha val="88000"/>
-              </a:srgbClr>
+              <a:srgbClr val="6D3B6E"/>
             </a:solidFill>
             <a:prstDash val="solid"/>
           </a:ln>
@@ -11598,8 +11719,8 @@
         </p:nvSpPr>
         <p:spPr>
           <a:xfrm>
-            <a:off x="731520" y="4032504"/>
-            <a:ext cx="548640" cy="762000"/>
+            <a:off x="777240" y="4206240"/>
+            <a:ext cx="548640" cy="548640"/>
           </a:xfrm>
           <a:prstGeom prst="rect">
             <a:avLst/>
@@ -11615,14 +11736,17 @@
               <a:buNone/>
             </a:pPr>
             <a:r>
-              <a:rPr lang="en-US" sz="2400" b="1" dirty="0">
-                <a:solidFill>
-                  <a:srgbClr val="6D3B6E"/>
-                </a:solidFill>
-              </a:rPr>
-              <a:t>✓</a:t>
-            </a:r>
-            <a:endParaRPr lang="en-US" sz="2400" dirty="0"/>
+              <a:rPr lang="en-US" sz="1600" b="1" dirty="0">
+                <a:solidFill>
+                  <a:srgbClr val="FFFFFF"/>
+                </a:solidFill>
+                <a:latin typeface="Cambria" pitchFamily="34" charset="0"/>
+                <a:ea typeface="Cambria" pitchFamily="34" charset="-122"/>
+                <a:cs typeface="Cambria" pitchFamily="34" charset="-120"/>
+              </a:rPr>
+              <a:t>?</a:t>
+            </a:r>
+            <a:endParaRPr lang="en-US" sz="1600" dirty="0"/>
           </a:p>
         </p:txBody>
       </p:sp>
@@ -11634,8 +11758,8 @@
         </p:nvSpPr>
         <p:spPr>
           <a:xfrm>
-            <a:off x="1463040" y="4032504"/>
-            <a:ext cx="9966960" cy="762000"/>
+            <a:off x="1600200" y="3931920"/>
+            <a:ext cx="9784080" cy="1097280"/>
           </a:xfrm>
           <a:prstGeom prst="rect">
             <a:avLst/>
@@ -11651,14 +11775,14 @@
               <a:buNone/>
             </a:pPr>
             <a:r>
-              <a:rPr lang="en-US" sz="1800" b="1" dirty="0">
+              <a:rPr lang="en-US" sz="2000" dirty="0">
                 <a:solidFill>
                   <a:srgbClr val="3B2A2A"/>
                 </a:solidFill>
               </a:rPr>
-              <a:t>Dados de saúde e deficiência são sensíveis: não os insira</a:t>
-            </a:r>
-            <a:endParaRPr lang="en-US" sz="1800" dirty="0"/>
+              <a:t>Que tarefa recorrente merece um teste de tempo com e sem IA?</a:t>
+            </a:r>
+            <a:endParaRPr lang="en-US" sz="2000" dirty="0"/>
           </a:p>
         </p:txBody>
       </p:sp>
@@ -11670,24 +11794,20 @@
         </p:nvSpPr>
         <p:spPr>
           <a:xfrm>
-            <a:off x="548640" y="4904232"/>
-            <a:ext cx="11064240" cy="762000"/>
+            <a:off x="548640" y="5166360"/>
+            <a:ext cx="11064240" cy="1097280"/>
           </a:xfrm>
           <a:prstGeom prst="roundRect">
             <a:avLst>
-              <a:gd name="adj" fmla="val 14400"/>
+              <a:gd name="adj" fmla="val 10000"/>
             </a:avLst>
           </a:prstGeom>
           <a:solidFill>
-            <a:srgbClr val="FFFFFF">
-              <a:alpha val="88000"/>
-            </a:srgbClr>
+            <a:srgbClr val="F7EFE6"/>
           </a:solidFill>
           <a:ln w="12700">
             <a:solidFill>
-              <a:srgbClr val="FFFFFF">
-                <a:alpha val="88000"/>
-              </a:srgbClr>
+              <a:srgbClr val="F7EFE6"/>
             </a:solidFill>
             <a:prstDash val="solid"/>
           </a:ln>
@@ -11695,102 +11815,24 @@
       </p:sp>
       <p:sp>
         <p:nvSpPr>
-          <p:cNvPr id="17" name="Text 14"/>
-          <p:cNvSpPr txBox="1"/>
-          <p:nvPr/>
-        </p:nvSpPr>
-        <p:spPr>
-          <a:xfrm>
-            <a:off x="731520" y="4904232"/>
-            <a:ext cx="548640" cy="762000"/>
-          </a:xfrm>
-          <a:prstGeom prst="rect">
-            <a:avLst/>
-          </a:prstGeom>
-          <a:noFill/>
-          <a:ln/>
-        </p:spPr>
-        <p:txBody>
-          <a:bodyPr wrap="square" lIns="0" tIns="0" rIns="0" bIns="0" rtlCol="0" anchor="ctr"/>
-          <a:lstStyle/>
-          <a:p>
-            <a:pPr algn="ctr" indent="0" marL="0">
-              <a:buNone/>
-            </a:pPr>
-            <a:r>
-              <a:rPr lang="en-US" sz="2400" b="1" dirty="0">
-                <a:solidFill>
-                  <a:srgbClr val="6D3B6E"/>
-                </a:solidFill>
-              </a:rPr>
-              <a:t>✓</a:t>
-            </a:r>
-            <a:endParaRPr lang="en-US" sz="2400" dirty="0"/>
-          </a:p>
-        </p:txBody>
-      </p:sp>
-      <p:sp>
-        <p:nvSpPr>
-          <p:cNvPr id="18" name="Text 15"/>
-          <p:cNvSpPr txBox="1"/>
-          <p:nvPr/>
-        </p:nvSpPr>
-        <p:spPr>
-          <a:xfrm>
-            <a:off x="1463040" y="4904232"/>
-            <a:ext cx="9966960" cy="762000"/>
-          </a:xfrm>
-          <a:prstGeom prst="rect">
-            <a:avLst/>
-          </a:prstGeom>
-          <a:noFill/>
-          <a:ln/>
-        </p:spPr>
-        <p:txBody>
-          <a:bodyPr wrap="square" lIns="0" tIns="0" rIns="0" bIns="0" rtlCol="0" anchor="ctr"/>
-          <a:lstStyle/>
-          <a:p>
-            <a:pPr indent="0" marL="0">
-              <a:buNone/>
-            </a:pPr>
-            <a:r>
-              <a:rPr lang="en-US" sz="1800" b="1" dirty="0">
-                <a:solidFill>
-                  <a:srgbClr val="3B2A2A"/>
-                </a:solidFill>
-              </a:rPr>
-              <a:t>Conte a revisão no tempo; use triagem, banco e limites</a:t>
-            </a:r>
-            <a:endParaRPr lang="en-US" sz="1800" dirty="0"/>
-          </a:p>
-        </p:txBody>
-      </p:sp>
-      <p:sp>
-        <p:nvSpPr>
-          <p:cNvPr id="19" name="Shape 16"/>
+          <p:cNvPr id="17" name="Shape 14"/>
           <p:cNvSpPr/>
           <p:nvPr/>
         </p:nvSpPr>
         <p:spPr>
           <a:xfrm>
-            <a:off x="548640" y="5775960"/>
-            <a:ext cx="11064240" cy="762000"/>
-          </a:xfrm>
-          <a:prstGeom prst="roundRect">
-            <a:avLst>
-              <a:gd name="adj" fmla="val 14400"/>
-            </a:avLst>
+            <a:off x="777240" y="5440680"/>
+            <a:ext cx="548640" cy="548640"/>
+          </a:xfrm>
+          <a:prstGeom prst="ellipse">
+            <a:avLst/>
           </a:prstGeom>
           <a:solidFill>
-            <a:srgbClr val="FFFFFF">
-              <a:alpha val="88000"/>
-            </a:srgbClr>
+            <a:srgbClr val="6D3B6E"/>
           </a:solidFill>
           <a:ln w="12700">
             <a:solidFill>
-              <a:srgbClr val="FFFFFF">
-                <a:alpha val="88000"/>
-              </a:srgbClr>
+              <a:srgbClr val="6D3B6E"/>
             </a:solidFill>
             <a:prstDash val="solid"/>
           </a:ln>
@@ -11798,79 +11840,82 @@
       </p:sp>
       <p:sp>
         <p:nvSpPr>
+          <p:cNvPr id="18" name="Text 15"/>
+          <p:cNvSpPr txBox="1"/>
+          <p:nvPr/>
+        </p:nvSpPr>
+        <p:spPr>
+          <a:xfrm>
+            <a:off x="777240" y="5440680"/>
+            <a:ext cx="548640" cy="548640"/>
+          </a:xfrm>
+          <a:prstGeom prst="rect">
+            <a:avLst/>
+          </a:prstGeom>
+          <a:noFill/>
+          <a:ln/>
+        </p:spPr>
+        <p:txBody>
+          <a:bodyPr wrap="square" lIns="0" tIns="0" rIns="0" bIns="0" rtlCol="0" anchor="ctr"/>
+          <a:lstStyle/>
+          <a:p>
+            <a:pPr algn="ctr" indent="0" marL="0">
+              <a:buNone/>
+            </a:pPr>
+            <a:r>
+              <a:rPr lang="en-US" sz="1600" b="1" dirty="0">
+                <a:solidFill>
+                  <a:srgbClr val="FFFFFF"/>
+                </a:solidFill>
+                <a:latin typeface="Cambria" pitchFamily="34" charset="0"/>
+                <a:ea typeface="Cambria" pitchFamily="34" charset="-122"/>
+                <a:cs typeface="Cambria" pitchFamily="34" charset="-120"/>
+              </a:rPr>
+              <a:t>?</a:t>
+            </a:r>
+            <a:endParaRPr lang="en-US" sz="1600" dirty="0"/>
+          </a:p>
+        </p:txBody>
+      </p:sp>
+      <p:sp>
+        <p:nvSpPr>
+          <p:cNvPr id="19" name="Text 16"/>
+          <p:cNvSpPr txBox="1"/>
+          <p:nvPr/>
+        </p:nvSpPr>
+        <p:spPr>
+          <a:xfrm>
+            <a:off x="1600200" y="5166360"/>
+            <a:ext cx="9784080" cy="1097280"/>
+          </a:xfrm>
+          <a:prstGeom prst="rect">
+            <a:avLst/>
+          </a:prstGeom>
+          <a:noFill/>
+          <a:ln/>
+        </p:spPr>
+        <p:txBody>
+          <a:bodyPr wrap="square" lIns="0" tIns="0" rIns="0" bIns="0" rtlCol="0" anchor="ctr"/>
+          <a:lstStyle/>
+          <a:p>
+            <a:pPr indent="0" marL="0">
+              <a:buNone/>
+            </a:pPr>
+            <a:r>
+              <a:rPr lang="en-US" sz="2000" dirty="0">
+                <a:solidFill>
+                  <a:srgbClr val="3B2A2A"/>
+                </a:solidFill>
+              </a:rPr>
+              <a:t>Que pergunta de prática você levaria a um grupo de estudo?</a:t>
+            </a:r>
+            <a:endParaRPr lang="en-US" sz="2000" dirty="0"/>
+          </a:p>
+        </p:txBody>
+      </p:sp>
+      <p:sp>
+        <p:nvSpPr>
           <p:cNvPr id="20" name="Text 17"/>
-          <p:cNvSpPr txBox="1"/>
-          <p:nvPr/>
-        </p:nvSpPr>
-        <p:spPr>
-          <a:xfrm>
-            <a:off x="731520" y="5775960"/>
-            <a:ext cx="548640" cy="762000"/>
-          </a:xfrm>
-          <a:prstGeom prst="rect">
-            <a:avLst/>
-          </a:prstGeom>
-          <a:noFill/>
-          <a:ln/>
-        </p:spPr>
-        <p:txBody>
-          <a:bodyPr wrap="square" lIns="0" tIns="0" rIns="0" bIns="0" rtlCol="0" anchor="ctr"/>
-          <a:lstStyle/>
-          <a:p>
-            <a:pPr algn="ctr" indent="0" marL="0">
-              <a:buNone/>
-            </a:pPr>
-            <a:r>
-              <a:rPr lang="en-US" sz="2400" b="1" dirty="0">
-                <a:solidFill>
-                  <a:srgbClr val="6D3B6E"/>
-                </a:solidFill>
-              </a:rPr>
-              <a:t>✓</a:t>
-            </a:r>
-            <a:endParaRPr lang="en-US" sz="2400" dirty="0"/>
-          </a:p>
-        </p:txBody>
-      </p:sp>
-      <p:sp>
-        <p:nvSpPr>
-          <p:cNvPr id="21" name="Text 18"/>
-          <p:cNvSpPr txBox="1"/>
-          <p:nvPr/>
-        </p:nvSpPr>
-        <p:spPr>
-          <a:xfrm>
-            <a:off x="1463040" y="5775960"/>
-            <a:ext cx="9966960" cy="762000"/>
-          </a:xfrm>
-          <a:prstGeom prst="rect">
-            <a:avLst/>
-          </a:prstGeom>
-          <a:noFill/>
-          <a:ln/>
-        </p:spPr>
-        <p:txBody>
-          <a:bodyPr wrap="square" lIns="0" tIns="0" rIns="0" bIns="0" rtlCol="0" anchor="ctr"/>
-          <a:lstStyle/>
-          <a:p>
-            <a:pPr indent="0" marL="0">
-              <a:buNone/>
-            </a:pPr>
-            <a:r>
-              <a:rPr lang="en-US" sz="1800" b="1" dirty="0">
-                <a:solidFill>
-                  <a:srgbClr val="3B2A2A"/>
-                </a:solidFill>
-              </a:rPr>
-              <a:t>Formação efetiva é ativa, colaborativa e contínua</a:t>
-            </a:r>
-            <a:endParaRPr lang="en-US" sz="1800" dirty="0"/>
-          </a:p>
-        </p:txBody>
-      </p:sp>
-      <p:sp>
-        <p:nvSpPr>
-          <p:cNvPr id="22" name="Text 19"/>
           <p:cNvSpPr txBox="1"/>
           <p:nvPr/>
         </p:nvSpPr>
@@ -11895,7 +11940,7 @@
             <a:r>
               <a:rPr lang="en-US" sz="1000" dirty="0">
                 <a:solidFill>
-                  <a:srgbClr val="E9D9C8"/>
+                  <a:srgbClr val="6B5F59"/>
                 </a:solidFill>
                 <a:latin typeface="Calibri" pitchFamily="34" charset="0"/>
                 <a:ea typeface="Calibri" pitchFamily="34" charset="-122"/>
@@ -11918,624 +11963,6 @@
 <file path=ppt/slides/slide24.xml><?xml version="1.0" encoding="utf-8"?>
 <p:sld xmlns:a="http://schemas.openxmlformats.org/drawingml/2006/main" xmlns:r="http://schemas.openxmlformats.org/officeDocument/2006/relationships" xmlns:p="http://schemas.openxmlformats.org/presentationml/2006/main">
   <p:cSld name="Slide 24">
-    <p:bg>
-      <p:bgPr>
-        <a:solidFill>
-          <a:srgbClr val="FFFFFF"/>
-        </a:solidFill>
-      </p:bgPr>
-    </p:bg>
-    <p:spTree>
-      <p:nvGrpSpPr>
-        <p:cNvPr id="1" name=""/>
-        <p:cNvGrpSpPr/>
-        <p:nvPr/>
-      </p:nvGrpSpPr>
-      <p:grpSpPr>
-        <a:xfrm>
-          <a:off x="0" y="0"/>
-          <a:ext cx="0" cy="0"/>
-          <a:chOff x="0" y="0"/>
-          <a:chExt cx="0" cy="0"/>
-        </a:xfrm>
-      </p:grpSpPr>
-      <p:sp>
-        <p:nvSpPr>
-          <p:cNvPr id="3" name="Text 0"/>
-          <p:cNvSpPr txBox="1"/>
-          <p:nvPr/>
-        </p:nvSpPr>
-        <p:spPr>
-          <a:xfrm>
-            <a:off x="548640" y="365760"/>
-            <a:ext cx="11064240" cy="822960"/>
-          </a:xfrm>
-          <a:prstGeom prst="rect">
-            <a:avLst/>
-          </a:prstGeom>
-          <a:noFill/>
-          <a:ln/>
-        </p:spPr>
-        <p:txBody>
-          <a:bodyPr wrap="square" lIns="0" tIns="0" rIns="0" bIns="0" rtlCol="0" anchor="t"/>
-          <a:lstStyle/>
-          <a:p>
-            <a:pPr indent="0" marL="0">
-              <a:buNone/>
-            </a:pPr>
-            <a:r>
-              <a:rPr lang="en-US" sz="3400" b="1" dirty="0">
-                <a:solidFill>
-                  <a:srgbClr val="5A2E2A"/>
-                </a:solidFill>
-                <a:latin typeface="Cambria" pitchFamily="34" charset="0"/>
-                <a:ea typeface="Cambria" pitchFamily="34" charset="-122"/>
-                <a:cs typeface="Cambria" pitchFamily="34" charset="-120"/>
-              </a:rPr>
-              <a:t>Para pensar na sua prática</a:t>
-            </a:r>
-            <a:endParaRPr lang="en-US" sz="3400" dirty="0"/>
-          </a:p>
-        </p:txBody>
-      </p:sp>
-      <p:sp>
-        <p:nvSpPr>
-          <p:cNvPr id="4" name="Shape 1"/>
-          <p:cNvSpPr/>
-          <p:nvPr/>
-        </p:nvSpPr>
-        <p:spPr>
-          <a:xfrm>
-            <a:off x="548640" y="1463040"/>
-            <a:ext cx="11064240" cy="1097280"/>
-          </a:xfrm>
-          <a:prstGeom prst="roundRect">
-            <a:avLst>
-              <a:gd name="adj" fmla="val 10000"/>
-            </a:avLst>
-          </a:prstGeom>
-          <a:solidFill>
-            <a:srgbClr val="F7EFE6"/>
-          </a:solidFill>
-          <a:ln w="12700">
-            <a:solidFill>
-              <a:srgbClr val="F7EFE6"/>
-            </a:solidFill>
-            <a:prstDash val="solid"/>
-          </a:ln>
-        </p:spPr>
-      </p:sp>
-      <p:sp>
-        <p:nvSpPr>
-          <p:cNvPr id="5" name="Shape 2"/>
-          <p:cNvSpPr/>
-          <p:nvPr/>
-        </p:nvSpPr>
-        <p:spPr>
-          <a:xfrm>
-            <a:off x="777240" y="1737360"/>
-            <a:ext cx="548640" cy="548640"/>
-          </a:xfrm>
-          <a:prstGeom prst="ellipse">
-            <a:avLst/>
-          </a:prstGeom>
-          <a:solidFill>
-            <a:srgbClr val="6D3B6E"/>
-          </a:solidFill>
-          <a:ln w="12700">
-            <a:solidFill>
-              <a:srgbClr val="6D3B6E"/>
-            </a:solidFill>
-            <a:prstDash val="solid"/>
-          </a:ln>
-        </p:spPr>
-      </p:sp>
-      <p:sp>
-        <p:nvSpPr>
-          <p:cNvPr id="6" name="Text 3"/>
-          <p:cNvSpPr txBox="1"/>
-          <p:nvPr/>
-        </p:nvSpPr>
-        <p:spPr>
-          <a:xfrm>
-            <a:off x="777240" y="1737360"/>
-            <a:ext cx="548640" cy="548640"/>
-          </a:xfrm>
-          <a:prstGeom prst="rect">
-            <a:avLst/>
-          </a:prstGeom>
-          <a:noFill/>
-          <a:ln/>
-        </p:spPr>
-        <p:txBody>
-          <a:bodyPr wrap="square" lIns="0" tIns="0" rIns="0" bIns="0" rtlCol="0" anchor="ctr"/>
-          <a:lstStyle/>
-          <a:p>
-            <a:pPr algn="ctr" indent="0" marL="0">
-              <a:buNone/>
-            </a:pPr>
-            <a:r>
-              <a:rPr lang="en-US" sz="1600" b="1" dirty="0">
-                <a:solidFill>
-                  <a:srgbClr val="FFFFFF"/>
-                </a:solidFill>
-                <a:latin typeface="Cambria" pitchFamily="34" charset="0"/>
-                <a:ea typeface="Cambria" pitchFamily="34" charset="-122"/>
-                <a:cs typeface="Cambria" pitchFamily="34" charset="-120"/>
-              </a:rPr>
-              <a:t>?</a:t>
-            </a:r>
-            <a:endParaRPr lang="en-US" sz="1600" dirty="0"/>
-          </a:p>
-        </p:txBody>
-      </p:sp>
-      <p:sp>
-        <p:nvSpPr>
-          <p:cNvPr id="7" name="Text 4"/>
-          <p:cNvSpPr txBox="1"/>
-          <p:nvPr/>
-        </p:nvSpPr>
-        <p:spPr>
-          <a:xfrm>
-            <a:off x="1600200" y="1463040"/>
-            <a:ext cx="9784080" cy="1097280"/>
-          </a:xfrm>
-          <a:prstGeom prst="rect">
-            <a:avLst/>
-          </a:prstGeom>
-          <a:noFill/>
-          <a:ln/>
-        </p:spPr>
-        <p:txBody>
-          <a:bodyPr wrap="square" lIns="0" tIns="0" rIns="0" bIns="0" rtlCol="0" anchor="ctr"/>
-          <a:lstStyle/>
-          <a:p>
-            <a:pPr indent="0" marL="0">
-              <a:buNone/>
-            </a:pPr>
-            <a:r>
-              <a:rPr lang="en-US" sz="2000" dirty="0">
-                <a:solidFill>
-                  <a:srgbClr val="3B2A2A"/>
-                </a:solidFill>
-              </a:rPr>
-              <a:t>Que barreira de acesso você reduziria esta semana, sem tecnologia?</a:t>
-            </a:r>
-            <a:endParaRPr lang="en-US" sz="2000" dirty="0"/>
-          </a:p>
-        </p:txBody>
-      </p:sp>
-      <p:sp>
-        <p:nvSpPr>
-          <p:cNvPr id="8" name="Shape 5"/>
-          <p:cNvSpPr/>
-          <p:nvPr/>
-        </p:nvSpPr>
-        <p:spPr>
-          <a:xfrm>
-            <a:off x="548640" y="2697480"/>
-            <a:ext cx="11064240" cy="1097280"/>
-          </a:xfrm>
-          <a:prstGeom prst="roundRect">
-            <a:avLst>
-              <a:gd name="adj" fmla="val 10000"/>
-            </a:avLst>
-          </a:prstGeom>
-          <a:solidFill>
-            <a:srgbClr val="F7EFE6"/>
-          </a:solidFill>
-          <a:ln w="12700">
-            <a:solidFill>
-              <a:srgbClr val="F7EFE6"/>
-            </a:solidFill>
-            <a:prstDash val="solid"/>
-          </a:ln>
-        </p:spPr>
-      </p:sp>
-      <p:sp>
-        <p:nvSpPr>
-          <p:cNvPr id="9" name="Shape 6"/>
-          <p:cNvSpPr/>
-          <p:nvPr/>
-        </p:nvSpPr>
-        <p:spPr>
-          <a:xfrm>
-            <a:off x="777240" y="2971800"/>
-            <a:ext cx="548640" cy="548640"/>
-          </a:xfrm>
-          <a:prstGeom prst="ellipse">
-            <a:avLst/>
-          </a:prstGeom>
-          <a:solidFill>
-            <a:srgbClr val="6D3B6E"/>
-          </a:solidFill>
-          <a:ln w="12700">
-            <a:solidFill>
-              <a:srgbClr val="6D3B6E"/>
-            </a:solidFill>
-            <a:prstDash val="solid"/>
-          </a:ln>
-        </p:spPr>
-      </p:sp>
-      <p:sp>
-        <p:nvSpPr>
-          <p:cNvPr id="10" name="Text 7"/>
-          <p:cNvSpPr txBox="1"/>
-          <p:nvPr/>
-        </p:nvSpPr>
-        <p:spPr>
-          <a:xfrm>
-            <a:off x="777240" y="2971800"/>
-            <a:ext cx="548640" cy="548640"/>
-          </a:xfrm>
-          <a:prstGeom prst="rect">
-            <a:avLst/>
-          </a:prstGeom>
-          <a:noFill/>
-          <a:ln/>
-        </p:spPr>
-        <p:txBody>
-          <a:bodyPr wrap="square" lIns="0" tIns="0" rIns="0" bIns="0" rtlCol="0" anchor="ctr"/>
-          <a:lstStyle/>
-          <a:p>
-            <a:pPr algn="ctr" indent="0" marL="0">
-              <a:buNone/>
-            </a:pPr>
-            <a:r>
-              <a:rPr lang="en-US" sz="1600" b="1" dirty="0">
-                <a:solidFill>
-                  <a:srgbClr val="FFFFFF"/>
-                </a:solidFill>
-                <a:latin typeface="Cambria" pitchFamily="34" charset="0"/>
-                <a:ea typeface="Cambria" pitchFamily="34" charset="-122"/>
-                <a:cs typeface="Cambria" pitchFamily="34" charset="-120"/>
-              </a:rPr>
-              <a:t>?</a:t>
-            </a:r>
-            <a:endParaRPr lang="en-US" sz="1600" dirty="0"/>
-          </a:p>
-        </p:txBody>
-      </p:sp>
-      <p:sp>
-        <p:nvSpPr>
-          <p:cNvPr id="11" name="Text 8"/>
-          <p:cNvSpPr txBox="1"/>
-          <p:nvPr/>
-        </p:nvSpPr>
-        <p:spPr>
-          <a:xfrm>
-            <a:off x="1600200" y="2697480"/>
-            <a:ext cx="9784080" cy="1097280"/>
-          </a:xfrm>
-          <a:prstGeom prst="rect">
-            <a:avLst/>
-          </a:prstGeom>
-          <a:noFill/>
-          <a:ln/>
-        </p:spPr>
-        <p:txBody>
-          <a:bodyPr wrap="square" lIns="0" tIns="0" rIns="0" bIns="0" rtlCol="0" anchor="ctr"/>
-          <a:lstStyle/>
-          <a:p>
-            <a:pPr indent="0" marL="0">
-              <a:buNone/>
-            </a:pPr>
-            <a:r>
-              <a:rPr lang="en-US" sz="2000" dirty="0">
-                <a:solidFill>
-                  <a:srgbClr val="3B2A2A"/>
-                </a:solidFill>
-              </a:rPr>
-              <a:t>Como você verifica uma descrição de imagem produzida por IA?</a:t>
-            </a:r>
-            <a:endParaRPr lang="en-US" sz="2000" dirty="0"/>
-          </a:p>
-        </p:txBody>
-      </p:sp>
-      <p:sp>
-        <p:nvSpPr>
-          <p:cNvPr id="12" name="Shape 9"/>
-          <p:cNvSpPr/>
-          <p:nvPr/>
-        </p:nvSpPr>
-        <p:spPr>
-          <a:xfrm>
-            <a:off x="548640" y="3931920"/>
-            <a:ext cx="11064240" cy="1097280"/>
-          </a:xfrm>
-          <a:prstGeom prst="roundRect">
-            <a:avLst>
-              <a:gd name="adj" fmla="val 10000"/>
-            </a:avLst>
-          </a:prstGeom>
-          <a:solidFill>
-            <a:srgbClr val="F7EFE6"/>
-          </a:solidFill>
-          <a:ln w="12700">
-            <a:solidFill>
-              <a:srgbClr val="F7EFE6"/>
-            </a:solidFill>
-            <a:prstDash val="solid"/>
-          </a:ln>
-        </p:spPr>
-      </p:sp>
-      <p:sp>
-        <p:nvSpPr>
-          <p:cNvPr id="13" name="Shape 10"/>
-          <p:cNvSpPr/>
-          <p:nvPr/>
-        </p:nvSpPr>
-        <p:spPr>
-          <a:xfrm>
-            <a:off x="777240" y="4206240"/>
-            <a:ext cx="548640" cy="548640"/>
-          </a:xfrm>
-          <a:prstGeom prst="ellipse">
-            <a:avLst/>
-          </a:prstGeom>
-          <a:solidFill>
-            <a:srgbClr val="6D3B6E"/>
-          </a:solidFill>
-          <a:ln w="12700">
-            <a:solidFill>
-              <a:srgbClr val="6D3B6E"/>
-            </a:solidFill>
-            <a:prstDash val="solid"/>
-          </a:ln>
-        </p:spPr>
-      </p:sp>
-      <p:sp>
-        <p:nvSpPr>
-          <p:cNvPr id="14" name="Text 11"/>
-          <p:cNvSpPr txBox="1"/>
-          <p:nvPr/>
-        </p:nvSpPr>
-        <p:spPr>
-          <a:xfrm>
-            <a:off x="777240" y="4206240"/>
-            <a:ext cx="548640" cy="548640"/>
-          </a:xfrm>
-          <a:prstGeom prst="rect">
-            <a:avLst/>
-          </a:prstGeom>
-          <a:noFill/>
-          <a:ln/>
-        </p:spPr>
-        <p:txBody>
-          <a:bodyPr wrap="square" lIns="0" tIns="0" rIns="0" bIns="0" rtlCol="0" anchor="ctr"/>
-          <a:lstStyle/>
-          <a:p>
-            <a:pPr algn="ctr" indent="0" marL="0">
-              <a:buNone/>
-            </a:pPr>
-            <a:r>
-              <a:rPr lang="en-US" sz="1600" b="1" dirty="0">
-                <a:solidFill>
-                  <a:srgbClr val="FFFFFF"/>
-                </a:solidFill>
-                <a:latin typeface="Cambria" pitchFamily="34" charset="0"/>
-                <a:ea typeface="Cambria" pitchFamily="34" charset="-122"/>
-                <a:cs typeface="Cambria" pitchFamily="34" charset="-120"/>
-              </a:rPr>
-              <a:t>?</a:t>
-            </a:r>
-            <a:endParaRPr lang="en-US" sz="1600" dirty="0"/>
-          </a:p>
-        </p:txBody>
-      </p:sp>
-      <p:sp>
-        <p:nvSpPr>
-          <p:cNvPr id="15" name="Text 12"/>
-          <p:cNvSpPr txBox="1"/>
-          <p:nvPr/>
-        </p:nvSpPr>
-        <p:spPr>
-          <a:xfrm>
-            <a:off x="1600200" y="3931920"/>
-            <a:ext cx="9784080" cy="1097280"/>
-          </a:xfrm>
-          <a:prstGeom prst="rect">
-            <a:avLst/>
-          </a:prstGeom>
-          <a:noFill/>
-          <a:ln/>
-        </p:spPr>
-        <p:txBody>
-          <a:bodyPr wrap="square" lIns="0" tIns="0" rIns="0" bIns="0" rtlCol="0" anchor="ctr"/>
-          <a:lstStyle/>
-          <a:p>
-            <a:pPr indent="0" marL="0">
-              <a:buNone/>
-            </a:pPr>
-            <a:r>
-              <a:rPr lang="en-US" sz="2000" dirty="0">
-                <a:solidFill>
-                  <a:srgbClr val="3B2A2A"/>
-                </a:solidFill>
-              </a:rPr>
-              <a:t>Que tarefa recorrente merece um teste de tempo com e sem IA?</a:t>
-            </a:r>
-            <a:endParaRPr lang="en-US" sz="2000" dirty="0"/>
-          </a:p>
-        </p:txBody>
-      </p:sp>
-      <p:sp>
-        <p:nvSpPr>
-          <p:cNvPr id="16" name="Shape 13"/>
-          <p:cNvSpPr/>
-          <p:nvPr/>
-        </p:nvSpPr>
-        <p:spPr>
-          <a:xfrm>
-            <a:off x="548640" y="5166360"/>
-            <a:ext cx="11064240" cy="1097280"/>
-          </a:xfrm>
-          <a:prstGeom prst="roundRect">
-            <a:avLst>
-              <a:gd name="adj" fmla="val 10000"/>
-            </a:avLst>
-          </a:prstGeom>
-          <a:solidFill>
-            <a:srgbClr val="F7EFE6"/>
-          </a:solidFill>
-          <a:ln w="12700">
-            <a:solidFill>
-              <a:srgbClr val="F7EFE6"/>
-            </a:solidFill>
-            <a:prstDash val="solid"/>
-          </a:ln>
-        </p:spPr>
-      </p:sp>
-      <p:sp>
-        <p:nvSpPr>
-          <p:cNvPr id="17" name="Shape 14"/>
-          <p:cNvSpPr/>
-          <p:nvPr/>
-        </p:nvSpPr>
-        <p:spPr>
-          <a:xfrm>
-            <a:off x="777240" y="5440680"/>
-            <a:ext cx="548640" cy="548640"/>
-          </a:xfrm>
-          <a:prstGeom prst="ellipse">
-            <a:avLst/>
-          </a:prstGeom>
-          <a:solidFill>
-            <a:srgbClr val="6D3B6E"/>
-          </a:solidFill>
-          <a:ln w="12700">
-            <a:solidFill>
-              <a:srgbClr val="6D3B6E"/>
-            </a:solidFill>
-            <a:prstDash val="solid"/>
-          </a:ln>
-        </p:spPr>
-      </p:sp>
-      <p:sp>
-        <p:nvSpPr>
-          <p:cNvPr id="18" name="Text 15"/>
-          <p:cNvSpPr txBox="1"/>
-          <p:nvPr/>
-        </p:nvSpPr>
-        <p:spPr>
-          <a:xfrm>
-            <a:off x="777240" y="5440680"/>
-            <a:ext cx="548640" cy="548640"/>
-          </a:xfrm>
-          <a:prstGeom prst="rect">
-            <a:avLst/>
-          </a:prstGeom>
-          <a:noFill/>
-          <a:ln/>
-        </p:spPr>
-        <p:txBody>
-          <a:bodyPr wrap="square" lIns="0" tIns="0" rIns="0" bIns="0" rtlCol="0" anchor="ctr"/>
-          <a:lstStyle/>
-          <a:p>
-            <a:pPr algn="ctr" indent="0" marL="0">
-              <a:buNone/>
-            </a:pPr>
-            <a:r>
-              <a:rPr lang="en-US" sz="1600" b="1" dirty="0">
-                <a:solidFill>
-                  <a:srgbClr val="FFFFFF"/>
-                </a:solidFill>
-                <a:latin typeface="Cambria" pitchFamily="34" charset="0"/>
-                <a:ea typeface="Cambria" pitchFamily="34" charset="-122"/>
-                <a:cs typeface="Cambria" pitchFamily="34" charset="-120"/>
-              </a:rPr>
-              <a:t>?</a:t>
-            </a:r>
-            <a:endParaRPr lang="en-US" sz="1600" dirty="0"/>
-          </a:p>
-        </p:txBody>
-      </p:sp>
-      <p:sp>
-        <p:nvSpPr>
-          <p:cNvPr id="19" name="Text 16"/>
-          <p:cNvSpPr txBox="1"/>
-          <p:nvPr/>
-        </p:nvSpPr>
-        <p:spPr>
-          <a:xfrm>
-            <a:off x="1600200" y="5166360"/>
-            <a:ext cx="9784080" cy="1097280"/>
-          </a:xfrm>
-          <a:prstGeom prst="rect">
-            <a:avLst/>
-          </a:prstGeom>
-          <a:noFill/>
-          <a:ln/>
-        </p:spPr>
-        <p:txBody>
-          <a:bodyPr wrap="square" lIns="0" tIns="0" rIns="0" bIns="0" rtlCol="0" anchor="ctr"/>
-          <a:lstStyle/>
-          <a:p>
-            <a:pPr indent="0" marL="0">
-              <a:buNone/>
-            </a:pPr>
-            <a:r>
-              <a:rPr lang="en-US" sz="2000" dirty="0">
-                <a:solidFill>
-                  <a:srgbClr val="3B2A2A"/>
-                </a:solidFill>
-              </a:rPr>
-              <a:t>Que pergunta de prática você levaria a um grupo de estudo?</a:t>
-            </a:r>
-            <a:endParaRPr lang="en-US" sz="2000" dirty="0"/>
-          </a:p>
-        </p:txBody>
-      </p:sp>
-      <p:sp>
-        <p:nvSpPr>
-          <p:cNvPr id="20" name="Text 17"/>
-          <p:cNvSpPr txBox="1"/>
-          <p:nvPr/>
-        </p:nvSpPr>
-        <p:spPr>
-          <a:xfrm>
-            <a:off x="548640" y="6446520"/>
-            <a:ext cx="5486400" cy="274320"/>
-          </a:xfrm>
-          <a:prstGeom prst="rect">
-            <a:avLst/>
-          </a:prstGeom>
-          <a:noFill/>
-          <a:ln/>
-        </p:spPr>
-        <p:txBody>
-          <a:bodyPr wrap="square" lIns="0" tIns="0" rIns="0" bIns="0" rtlCol="0" anchor="ctr"/>
-          <a:lstStyle/>
-          <a:p>
-            <a:pPr indent="0" marL="0">
-              <a:buNone/>
-            </a:pPr>
-            <a:r>
-              <a:rPr lang="en-US" sz="1000" dirty="0">
-                <a:solidFill>
-                  <a:srgbClr val="6B5F59"/>
-                </a:solidFill>
-                <a:latin typeface="Calibri" pitchFamily="34" charset="0"/>
-                <a:ea typeface="Calibri" pitchFamily="34" charset="-122"/>
-                <a:cs typeface="Calibri" pitchFamily="34" charset="-120"/>
-              </a:rPr>
-              <a:t>IA aplicada à Educação · Cap. 23</a:t>
-            </a:r>
-            <a:endParaRPr lang="en-US" sz="1000" dirty="0"/>
-          </a:p>
-        </p:txBody>
-      </p:sp>
-    </p:spTree>
-  </p:cSld>
-  <p:clrMapOvr>
-    <a:masterClrMapping/>
-  </p:clrMapOvr>
-</p:sld>
-</file>
-
-<file path=ppt/slides/slide25.xml><?xml version="1.0" encoding="utf-8"?>
-<p:sld xmlns:a="http://schemas.openxmlformats.org/drawingml/2006/main" xmlns:r="http://schemas.openxmlformats.org/officeDocument/2006/relationships" xmlns:p="http://schemas.openxmlformats.org/presentationml/2006/main">
-  <p:cSld name="Slide 25">
     <p:bg>
       <p:bgPr>
         <a:solidFill>

</xml_diff>